<commit_message>
docs: 更新 SURUGA SEIKI.pptx
Co-Authored-By: Claude Sonnet 5 <noreply@anthropic.com>
</commit_message>
<xml_diff>
--- a/SURUGA SEIKI.pptx
+++ b/SURUGA SEIKI.pptx
@@ -11,7 +11,30 @@
     <p:sldId id="259" r:id="rId5"/>
     <p:sldId id="260" r:id="rId6"/>
     <p:sldId id="261" r:id="rId7"/>
-    <p:sldId id="262" r:id="rId8"/>
+    <p:sldId id="287" r:id="rId8"/>
+    <p:sldId id="262" r:id="rId9"/>
+    <p:sldId id="273" r:id="rId10"/>
+    <p:sldId id="274" r:id="rId11"/>
+    <p:sldId id="275" r:id="rId12"/>
+    <p:sldId id="276" r:id="rId13"/>
+    <p:sldId id="277" r:id="rId14"/>
+    <p:sldId id="278" r:id="rId15"/>
+    <p:sldId id="268" r:id="rId16"/>
+    <p:sldId id="272" r:id="rId17"/>
+    <p:sldId id="264" r:id="rId18"/>
+    <p:sldId id="271" r:id="rId19"/>
+    <p:sldId id="263" r:id="rId20"/>
+    <p:sldId id="267" r:id="rId21"/>
+    <p:sldId id="269" r:id="rId22"/>
+    <p:sldId id="266" r:id="rId23"/>
+    <p:sldId id="270" r:id="rId24"/>
+    <p:sldId id="265" r:id="rId25"/>
+    <p:sldId id="279" r:id="rId26"/>
+    <p:sldId id="280" r:id="rId27"/>
+    <p:sldId id="281" r:id="rId28"/>
+    <p:sldId id="283" r:id="rId29"/>
+    <p:sldId id="282" r:id="rId30"/>
+    <p:sldId id="284" r:id="rId31"/>
   </p:sldIdLst>
   <p:sldSz cx="9144000" cy="6858000" type="screen4x3"/>
   <p:notesSz cx="6858000" cy="9144000"/>
@@ -294,7 +317,7 @@
           <a:p>
             <a:fld id="{AB340C54-136F-426F-A1A3-E6864C8CB219}" type="datetimeFigureOut">
               <a:rPr lang="zh-TW" altLang="en-US" smtClean="0"/>
-              <a:t>2026/8/3</a:t>
+              <a:t>2026/8/12</a:t>
             </a:fld>
             <a:endParaRPr lang="zh-TW" altLang="en-US"/>
           </a:p>
@@ -464,7 +487,7 @@
           <a:p>
             <a:fld id="{AB340C54-136F-426F-A1A3-E6864C8CB219}" type="datetimeFigureOut">
               <a:rPr lang="zh-TW" altLang="en-US" smtClean="0"/>
-              <a:t>2026/8/3</a:t>
+              <a:t>2026/8/12</a:t>
             </a:fld>
             <a:endParaRPr lang="zh-TW" altLang="en-US"/>
           </a:p>
@@ -644,7 +667,7 @@
           <a:p>
             <a:fld id="{AB340C54-136F-426F-A1A3-E6864C8CB219}" type="datetimeFigureOut">
               <a:rPr lang="zh-TW" altLang="en-US" smtClean="0"/>
-              <a:t>2026/8/3</a:t>
+              <a:t>2026/8/12</a:t>
             </a:fld>
             <a:endParaRPr lang="zh-TW" altLang="en-US"/>
           </a:p>
@@ -814,7 +837,7 @@
           <a:p>
             <a:fld id="{AB340C54-136F-426F-A1A3-E6864C8CB219}" type="datetimeFigureOut">
               <a:rPr lang="zh-TW" altLang="en-US" smtClean="0"/>
-              <a:t>2026/8/3</a:t>
+              <a:t>2026/8/12</a:t>
             </a:fld>
             <a:endParaRPr lang="zh-TW" altLang="en-US"/>
           </a:p>
@@ -1060,7 +1083,7 @@
           <a:p>
             <a:fld id="{AB340C54-136F-426F-A1A3-E6864C8CB219}" type="datetimeFigureOut">
               <a:rPr lang="zh-TW" altLang="en-US" smtClean="0"/>
-              <a:t>2026/8/3</a:t>
+              <a:t>2026/8/12</a:t>
             </a:fld>
             <a:endParaRPr lang="zh-TW" altLang="en-US"/>
           </a:p>
@@ -1348,7 +1371,7 @@
           <a:p>
             <a:fld id="{AB340C54-136F-426F-A1A3-E6864C8CB219}" type="datetimeFigureOut">
               <a:rPr lang="zh-TW" altLang="en-US" smtClean="0"/>
-              <a:t>2026/8/3</a:t>
+              <a:t>2026/8/12</a:t>
             </a:fld>
             <a:endParaRPr lang="zh-TW" altLang="en-US"/>
           </a:p>
@@ -1770,7 +1793,7 @@
           <a:p>
             <a:fld id="{AB340C54-136F-426F-A1A3-E6864C8CB219}" type="datetimeFigureOut">
               <a:rPr lang="zh-TW" altLang="en-US" smtClean="0"/>
-              <a:t>2026/8/3</a:t>
+              <a:t>2026/8/12</a:t>
             </a:fld>
             <a:endParaRPr lang="zh-TW" altLang="en-US"/>
           </a:p>
@@ -1888,7 +1911,7 @@
           <a:p>
             <a:fld id="{AB340C54-136F-426F-A1A3-E6864C8CB219}" type="datetimeFigureOut">
               <a:rPr lang="zh-TW" altLang="en-US" smtClean="0"/>
-              <a:t>2026/8/3</a:t>
+              <a:t>2026/8/12</a:t>
             </a:fld>
             <a:endParaRPr lang="zh-TW" altLang="en-US"/>
           </a:p>
@@ -1983,7 +2006,7 @@
           <a:p>
             <a:fld id="{AB340C54-136F-426F-A1A3-E6864C8CB219}" type="datetimeFigureOut">
               <a:rPr lang="zh-TW" altLang="en-US" smtClean="0"/>
-              <a:t>2026/8/3</a:t>
+              <a:t>2026/8/12</a:t>
             </a:fld>
             <a:endParaRPr lang="zh-TW" altLang="en-US"/>
           </a:p>
@@ -2260,7 +2283,7 @@
           <a:p>
             <a:fld id="{AB340C54-136F-426F-A1A3-E6864C8CB219}" type="datetimeFigureOut">
               <a:rPr lang="zh-TW" altLang="en-US" smtClean="0"/>
-              <a:t>2026/8/3</a:t>
+              <a:t>2026/8/12</a:t>
             </a:fld>
             <a:endParaRPr lang="zh-TW" altLang="en-US"/>
           </a:p>
@@ -2513,7 +2536,7 @@
           <a:p>
             <a:fld id="{AB340C54-136F-426F-A1A3-E6864C8CB219}" type="datetimeFigureOut">
               <a:rPr lang="zh-TW" altLang="en-US" smtClean="0"/>
-              <a:t>2026/8/3</a:t>
+              <a:t>2026/8/12</a:t>
             </a:fld>
             <a:endParaRPr lang="zh-TW" altLang="en-US"/>
           </a:p>
@@ -2735,7 +2758,7 @@
           <a:p>
             <a:fld id="{AB340C54-136F-426F-A1A3-E6864C8CB219}" type="datetimeFigureOut">
               <a:rPr lang="zh-TW" altLang="en-US" smtClean="0"/>
-              <a:t>2026/8/3</a:t>
+              <a:t>2026/8/12</a:t>
             </a:fld>
             <a:endParaRPr lang="zh-TW" altLang="en-US"/>
           </a:p>
@@ -3233,6 +3256,1377 @@
 </p:sld>
 </file>
 
+<file path=ppt/slides/slide10.xml><?xml version="1.0" encoding="utf-8"?>
+<p:sld xmlns:a="http://schemas.openxmlformats.org/drawingml/2006/main" xmlns:r="http://schemas.openxmlformats.org/officeDocument/2006/relationships" xmlns:p="http://schemas.openxmlformats.org/presentationml/2006/main">
+  <p:cSld>
+    <p:spTree>
+      <p:nvGrpSpPr>
+        <p:cNvPr id="1" name=""/>
+        <p:cNvGrpSpPr/>
+        <p:nvPr/>
+      </p:nvGrpSpPr>
+      <p:grpSpPr>
+        <a:xfrm>
+          <a:off x="0" y="0"/>
+          <a:ext cx="0" cy="0"/>
+          <a:chOff x="0" y="0"/>
+          <a:chExt cx="0" cy="0"/>
+        </a:xfrm>
+      </p:grpSpPr>
+      <p:sp>
+        <p:nvSpPr>
+          <p:cNvPr id="2" name="標題 1"/>
+          <p:cNvSpPr>
+            <a:spLocks noGrp="1"/>
+          </p:cNvSpPr>
+          <p:nvPr>
+            <p:ph type="title"/>
+          </p:nvPr>
+        </p:nvSpPr>
+        <p:spPr/>
+        <p:txBody>
+          <a:bodyPr/>
+          <a:lstStyle/>
+          <a:p>
+            <a:endParaRPr lang="zh-TW" altLang="en-US"/>
+          </a:p>
+        </p:txBody>
+      </p:sp>
+      <p:pic>
+        <p:nvPicPr>
+          <p:cNvPr id="17411" name="Picture 3"/>
+          <p:cNvPicPr>
+            <a:picLocks noGrp="1" noChangeAspect="1" noChangeArrowheads="1"/>
+          </p:cNvPicPr>
+          <p:nvPr>
+            <p:ph idx="1"/>
+          </p:nvPr>
+        </p:nvPicPr>
+        <p:blipFill>
+          <a:blip r:embed="rId2">
+            <a:extLst>
+              <a:ext uri="{28A0092B-C50C-407E-A947-70E740481C1C}">
+                <a14:useLocalDpi xmlns:a14="http://schemas.microsoft.com/office/drawing/2010/main" val="0"/>
+              </a:ext>
+            </a:extLst>
+          </a:blip>
+          <a:srcRect/>
+          <a:stretch>
+            <a:fillRect/>
+          </a:stretch>
+        </p:blipFill>
+        <p:spPr bwMode="auto">
+          <a:xfrm>
+            <a:off x="971600" y="764704"/>
+            <a:ext cx="6853109" cy="5498165"/>
+          </a:xfrm>
+          <a:prstGeom prst="rect">
+            <a:avLst/>
+          </a:prstGeom>
+          <a:noFill/>
+          <a:ln>
+            <a:noFill/>
+          </a:ln>
+          <a:effectLst/>
+          <a:extLst>
+            <a:ext uri="{909E8E84-426E-40DD-AFC4-6F175D3DCCD1}">
+              <a14:hiddenFill xmlns:a14="http://schemas.microsoft.com/office/drawing/2010/main">
+                <a:solidFill>
+                  <a:schemeClr val="accent1"/>
+                </a:solidFill>
+              </a14:hiddenFill>
+            </a:ext>
+            <a:ext uri="{91240B29-F687-4F45-9708-019B960494DF}">
+              <a14:hiddenLine xmlns:a14="http://schemas.microsoft.com/office/drawing/2010/main" w="9525">
+                <a:solidFill>
+                  <a:schemeClr val="tx1"/>
+                </a:solidFill>
+                <a:miter lim="800000"/>
+                <a:headEnd/>
+                <a:tailEnd/>
+              </a14:hiddenLine>
+            </a:ext>
+            <a:ext uri="{AF507438-7753-43E0-B8FC-AC1667EBCBE1}">
+              <a14:hiddenEffects xmlns:a14="http://schemas.microsoft.com/office/drawing/2010/main">
+                <a:effectLst>
+                  <a:outerShdw dist="35921" dir="2700000" algn="ctr" rotWithShape="0">
+                    <a:schemeClr val="bg2"/>
+                  </a:outerShdw>
+                </a:effectLst>
+              </a14:hiddenEffects>
+            </a:ext>
+          </a:extLst>
+        </p:spPr>
+      </p:pic>
+    </p:spTree>
+    <p:extLst>
+      <p:ext uri="{BB962C8B-B14F-4D97-AF65-F5344CB8AC3E}">
+        <p14:creationId xmlns:p14="http://schemas.microsoft.com/office/powerpoint/2010/main" val="405270947"/>
+      </p:ext>
+    </p:extLst>
+  </p:cSld>
+  <p:clrMapOvr>
+    <a:masterClrMapping/>
+  </p:clrMapOvr>
+</p:sld>
+</file>
+
+<file path=ppt/slides/slide11.xml><?xml version="1.0" encoding="utf-8"?>
+<p:sld xmlns:a="http://schemas.openxmlformats.org/drawingml/2006/main" xmlns:r="http://schemas.openxmlformats.org/officeDocument/2006/relationships" xmlns:p="http://schemas.openxmlformats.org/presentationml/2006/main">
+  <p:cSld>
+    <p:spTree>
+      <p:nvGrpSpPr>
+        <p:cNvPr id="1" name=""/>
+        <p:cNvGrpSpPr/>
+        <p:nvPr/>
+      </p:nvGrpSpPr>
+      <p:grpSpPr>
+        <a:xfrm>
+          <a:off x="0" y="0"/>
+          <a:ext cx="0" cy="0"/>
+          <a:chOff x="0" y="0"/>
+          <a:chExt cx="0" cy="0"/>
+        </a:xfrm>
+      </p:grpSpPr>
+      <p:sp>
+        <p:nvSpPr>
+          <p:cNvPr id="2" name="標題 1"/>
+          <p:cNvSpPr>
+            <a:spLocks noGrp="1"/>
+          </p:cNvSpPr>
+          <p:nvPr>
+            <p:ph type="title"/>
+          </p:nvPr>
+        </p:nvSpPr>
+        <p:spPr/>
+        <p:txBody>
+          <a:bodyPr/>
+          <a:lstStyle/>
+          <a:p>
+            <a:endParaRPr lang="zh-TW" altLang="en-US"/>
+          </a:p>
+        </p:txBody>
+      </p:sp>
+      <p:pic>
+        <p:nvPicPr>
+          <p:cNvPr id="18434" name="Picture 2"/>
+          <p:cNvPicPr>
+            <a:picLocks noGrp="1" noChangeAspect="1" noChangeArrowheads="1"/>
+          </p:cNvPicPr>
+          <p:nvPr>
+            <p:ph idx="1"/>
+          </p:nvPr>
+        </p:nvPicPr>
+        <p:blipFill>
+          <a:blip r:embed="rId2">
+            <a:extLst>
+              <a:ext uri="{28A0092B-C50C-407E-A947-70E740481C1C}">
+                <a14:useLocalDpi xmlns:a14="http://schemas.microsoft.com/office/drawing/2010/main" val="0"/>
+              </a:ext>
+            </a:extLst>
+          </a:blip>
+          <a:srcRect/>
+          <a:stretch>
+            <a:fillRect/>
+          </a:stretch>
+        </p:blipFill>
+        <p:spPr bwMode="auto">
+          <a:xfrm>
+            <a:off x="683568" y="764688"/>
+            <a:ext cx="6728344" cy="5361475"/>
+          </a:xfrm>
+          <a:prstGeom prst="rect">
+            <a:avLst/>
+          </a:prstGeom>
+          <a:noFill/>
+          <a:ln>
+            <a:noFill/>
+          </a:ln>
+          <a:effectLst/>
+          <a:extLst>
+            <a:ext uri="{909E8E84-426E-40DD-AFC4-6F175D3DCCD1}">
+              <a14:hiddenFill xmlns:a14="http://schemas.microsoft.com/office/drawing/2010/main">
+                <a:solidFill>
+                  <a:schemeClr val="accent1"/>
+                </a:solidFill>
+              </a14:hiddenFill>
+            </a:ext>
+            <a:ext uri="{91240B29-F687-4F45-9708-019B960494DF}">
+              <a14:hiddenLine xmlns:a14="http://schemas.microsoft.com/office/drawing/2010/main" w="9525">
+                <a:solidFill>
+                  <a:schemeClr val="tx1"/>
+                </a:solidFill>
+                <a:miter lim="800000"/>
+                <a:headEnd/>
+                <a:tailEnd/>
+              </a14:hiddenLine>
+            </a:ext>
+            <a:ext uri="{AF507438-7753-43E0-B8FC-AC1667EBCBE1}">
+              <a14:hiddenEffects xmlns:a14="http://schemas.microsoft.com/office/drawing/2010/main">
+                <a:effectLst>
+                  <a:outerShdw dist="35921" dir="2700000" algn="ctr" rotWithShape="0">
+                    <a:schemeClr val="bg2"/>
+                  </a:outerShdw>
+                </a:effectLst>
+              </a14:hiddenEffects>
+            </a:ext>
+          </a:extLst>
+        </p:spPr>
+      </p:pic>
+    </p:spTree>
+    <p:extLst>
+      <p:ext uri="{BB962C8B-B14F-4D97-AF65-F5344CB8AC3E}">
+        <p14:creationId xmlns:p14="http://schemas.microsoft.com/office/powerpoint/2010/main" val="2726799632"/>
+      </p:ext>
+    </p:extLst>
+  </p:cSld>
+  <p:clrMapOvr>
+    <a:masterClrMapping/>
+  </p:clrMapOvr>
+</p:sld>
+</file>
+
+<file path=ppt/slides/slide12.xml><?xml version="1.0" encoding="utf-8"?>
+<p:sld xmlns:a="http://schemas.openxmlformats.org/drawingml/2006/main" xmlns:r="http://schemas.openxmlformats.org/officeDocument/2006/relationships" xmlns:p="http://schemas.openxmlformats.org/presentationml/2006/main">
+  <p:cSld>
+    <p:spTree>
+      <p:nvGrpSpPr>
+        <p:cNvPr id="1" name=""/>
+        <p:cNvGrpSpPr/>
+        <p:nvPr/>
+      </p:nvGrpSpPr>
+      <p:grpSpPr>
+        <a:xfrm>
+          <a:off x="0" y="0"/>
+          <a:ext cx="0" cy="0"/>
+          <a:chOff x="0" y="0"/>
+          <a:chExt cx="0" cy="0"/>
+        </a:xfrm>
+      </p:grpSpPr>
+      <p:sp>
+        <p:nvSpPr>
+          <p:cNvPr id="2" name="標題 1"/>
+          <p:cNvSpPr>
+            <a:spLocks noGrp="1"/>
+          </p:cNvSpPr>
+          <p:nvPr>
+            <p:ph type="title"/>
+          </p:nvPr>
+        </p:nvSpPr>
+        <p:spPr/>
+        <p:txBody>
+          <a:bodyPr/>
+          <a:lstStyle/>
+          <a:p>
+            <a:endParaRPr lang="zh-TW" altLang="en-US"/>
+          </a:p>
+        </p:txBody>
+      </p:sp>
+      <p:pic>
+        <p:nvPicPr>
+          <p:cNvPr id="19458" name="Picture 2"/>
+          <p:cNvPicPr>
+            <a:picLocks noGrp="1" noChangeAspect="1" noChangeArrowheads="1"/>
+          </p:cNvPicPr>
+          <p:nvPr>
+            <p:ph idx="1"/>
+          </p:nvPr>
+        </p:nvPicPr>
+        <p:blipFill>
+          <a:blip r:embed="rId2">
+            <a:extLst>
+              <a:ext uri="{28A0092B-C50C-407E-A947-70E740481C1C}">
+                <a14:useLocalDpi xmlns:a14="http://schemas.microsoft.com/office/drawing/2010/main" val="0"/>
+              </a:ext>
+            </a:extLst>
+          </a:blip>
+          <a:srcRect/>
+          <a:stretch>
+            <a:fillRect/>
+          </a:stretch>
+        </p:blipFill>
+        <p:spPr bwMode="auto">
+          <a:xfrm>
+            <a:off x="1475656" y="1360903"/>
+            <a:ext cx="6212323" cy="5020425"/>
+          </a:xfrm>
+          <a:prstGeom prst="rect">
+            <a:avLst/>
+          </a:prstGeom>
+          <a:noFill/>
+          <a:ln>
+            <a:noFill/>
+          </a:ln>
+          <a:effectLst/>
+          <a:extLst>
+            <a:ext uri="{909E8E84-426E-40DD-AFC4-6F175D3DCCD1}">
+              <a14:hiddenFill xmlns:a14="http://schemas.microsoft.com/office/drawing/2010/main">
+                <a:solidFill>
+                  <a:schemeClr val="accent1"/>
+                </a:solidFill>
+              </a14:hiddenFill>
+            </a:ext>
+            <a:ext uri="{91240B29-F687-4F45-9708-019B960494DF}">
+              <a14:hiddenLine xmlns:a14="http://schemas.microsoft.com/office/drawing/2010/main" w="9525">
+                <a:solidFill>
+                  <a:schemeClr val="tx1"/>
+                </a:solidFill>
+                <a:miter lim="800000"/>
+                <a:headEnd/>
+                <a:tailEnd/>
+              </a14:hiddenLine>
+            </a:ext>
+            <a:ext uri="{AF507438-7753-43E0-B8FC-AC1667EBCBE1}">
+              <a14:hiddenEffects xmlns:a14="http://schemas.microsoft.com/office/drawing/2010/main">
+                <a:effectLst>
+                  <a:outerShdw dist="35921" dir="2700000" algn="ctr" rotWithShape="0">
+                    <a:schemeClr val="bg2"/>
+                  </a:outerShdw>
+                </a:effectLst>
+              </a14:hiddenEffects>
+            </a:ext>
+          </a:extLst>
+        </p:spPr>
+      </p:pic>
+    </p:spTree>
+    <p:extLst>
+      <p:ext uri="{BB962C8B-B14F-4D97-AF65-F5344CB8AC3E}">
+        <p14:creationId xmlns:p14="http://schemas.microsoft.com/office/powerpoint/2010/main" val="3710268482"/>
+      </p:ext>
+    </p:extLst>
+  </p:cSld>
+  <p:clrMapOvr>
+    <a:masterClrMapping/>
+  </p:clrMapOvr>
+</p:sld>
+</file>
+
+<file path=ppt/slides/slide13.xml><?xml version="1.0" encoding="utf-8"?>
+<p:sld xmlns:a="http://schemas.openxmlformats.org/drawingml/2006/main" xmlns:r="http://schemas.openxmlformats.org/officeDocument/2006/relationships" xmlns:p="http://schemas.openxmlformats.org/presentationml/2006/main">
+  <p:cSld>
+    <p:spTree>
+      <p:nvGrpSpPr>
+        <p:cNvPr id="1" name=""/>
+        <p:cNvGrpSpPr/>
+        <p:nvPr/>
+      </p:nvGrpSpPr>
+      <p:grpSpPr>
+        <a:xfrm>
+          <a:off x="0" y="0"/>
+          <a:ext cx="0" cy="0"/>
+          <a:chOff x="0" y="0"/>
+          <a:chExt cx="0" cy="0"/>
+        </a:xfrm>
+      </p:grpSpPr>
+      <p:sp>
+        <p:nvSpPr>
+          <p:cNvPr id="2" name="標題 1"/>
+          <p:cNvSpPr>
+            <a:spLocks noGrp="1"/>
+          </p:cNvSpPr>
+          <p:nvPr>
+            <p:ph type="title"/>
+          </p:nvPr>
+        </p:nvSpPr>
+        <p:spPr/>
+        <p:txBody>
+          <a:bodyPr/>
+          <a:lstStyle/>
+          <a:p>
+            <a:endParaRPr lang="zh-TW" altLang="en-US"/>
+          </a:p>
+        </p:txBody>
+      </p:sp>
+      <p:pic>
+        <p:nvPicPr>
+          <p:cNvPr id="20483" name="Picture 3"/>
+          <p:cNvPicPr>
+            <a:picLocks noGrp="1" noChangeAspect="1" noChangeArrowheads="1"/>
+          </p:cNvPicPr>
+          <p:nvPr>
+            <p:ph idx="1"/>
+          </p:nvPr>
+        </p:nvPicPr>
+        <p:blipFill>
+          <a:blip r:embed="rId2">
+            <a:extLst>
+              <a:ext uri="{28A0092B-C50C-407E-A947-70E740481C1C}">
+                <a14:useLocalDpi xmlns:a14="http://schemas.microsoft.com/office/drawing/2010/main" val="0"/>
+              </a:ext>
+            </a:extLst>
+          </a:blip>
+          <a:srcRect/>
+          <a:stretch>
+            <a:fillRect/>
+          </a:stretch>
+        </p:blipFill>
+        <p:spPr bwMode="auto">
+          <a:xfrm>
+            <a:off x="899592" y="1152584"/>
+            <a:ext cx="6477681" cy="5225471"/>
+          </a:xfrm>
+          <a:prstGeom prst="rect">
+            <a:avLst/>
+          </a:prstGeom>
+          <a:noFill/>
+          <a:ln>
+            <a:noFill/>
+          </a:ln>
+          <a:effectLst/>
+          <a:extLst>
+            <a:ext uri="{909E8E84-426E-40DD-AFC4-6F175D3DCCD1}">
+              <a14:hiddenFill xmlns:a14="http://schemas.microsoft.com/office/drawing/2010/main">
+                <a:solidFill>
+                  <a:schemeClr val="accent1"/>
+                </a:solidFill>
+              </a14:hiddenFill>
+            </a:ext>
+            <a:ext uri="{91240B29-F687-4F45-9708-019B960494DF}">
+              <a14:hiddenLine xmlns:a14="http://schemas.microsoft.com/office/drawing/2010/main" w="9525">
+                <a:solidFill>
+                  <a:schemeClr val="tx1"/>
+                </a:solidFill>
+                <a:miter lim="800000"/>
+                <a:headEnd/>
+                <a:tailEnd/>
+              </a14:hiddenLine>
+            </a:ext>
+            <a:ext uri="{AF507438-7753-43E0-B8FC-AC1667EBCBE1}">
+              <a14:hiddenEffects xmlns:a14="http://schemas.microsoft.com/office/drawing/2010/main">
+                <a:effectLst>
+                  <a:outerShdw dist="35921" dir="2700000" algn="ctr" rotWithShape="0">
+                    <a:schemeClr val="bg2"/>
+                  </a:outerShdw>
+                </a:effectLst>
+              </a14:hiddenEffects>
+            </a:ext>
+          </a:extLst>
+        </p:spPr>
+      </p:pic>
+    </p:spTree>
+    <p:extLst>
+      <p:ext uri="{BB962C8B-B14F-4D97-AF65-F5344CB8AC3E}">
+        <p14:creationId xmlns:p14="http://schemas.microsoft.com/office/powerpoint/2010/main" val="217124486"/>
+      </p:ext>
+    </p:extLst>
+  </p:cSld>
+  <p:clrMapOvr>
+    <a:masterClrMapping/>
+  </p:clrMapOvr>
+</p:sld>
+</file>
+
+<file path=ppt/slides/slide14.xml><?xml version="1.0" encoding="utf-8"?>
+<p:sld xmlns:a="http://schemas.openxmlformats.org/drawingml/2006/main" xmlns:r="http://schemas.openxmlformats.org/officeDocument/2006/relationships" xmlns:p="http://schemas.openxmlformats.org/presentationml/2006/main">
+  <p:cSld>
+    <p:spTree>
+      <p:nvGrpSpPr>
+        <p:cNvPr id="1" name=""/>
+        <p:cNvGrpSpPr/>
+        <p:nvPr/>
+      </p:nvGrpSpPr>
+      <p:grpSpPr>
+        <a:xfrm>
+          <a:off x="0" y="0"/>
+          <a:ext cx="0" cy="0"/>
+          <a:chOff x="0" y="0"/>
+          <a:chExt cx="0" cy="0"/>
+        </a:xfrm>
+      </p:grpSpPr>
+      <p:sp>
+        <p:nvSpPr>
+          <p:cNvPr id="2" name="標題 1"/>
+          <p:cNvSpPr>
+            <a:spLocks noGrp="1"/>
+          </p:cNvSpPr>
+          <p:nvPr>
+            <p:ph type="title"/>
+          </p:nvPr>
+        </p:nvSpPr>
+        <p:spPr/>
+        <p:txBody>
+          <a:bodyPr/>
+          <a:lstStyle/>
+          <a:p>
+            <a:endParaRPr lang="zh-TW" altLang="en-US"/>
+          </a:p>
+        </p:txBody>
+      </p:sp>
+      <p:pic>
+        <p:nvPicPr>
+          <p:cNvPr id="21506" name="Picture 2"/>
+          <p:cNvPicPr>
+            <a:picLocks noGrp="1" noChangeAspect="1" noChangeArrowheads="1"/>
+          </p:cNvPicPr>
+          <p:nvPr>
+            <p:ph idx="1"/>
+          </p:nvPr>
+        </p:nvPicPr>
+        <p:blipFill>
+          <a:blip r:embed="rId2">
+            <a:extLst>
+              <a:ext uri="{28A0092B-C50C-407E-A947-70E740481C1C}">
+                <a14:useLocalDpi xmlns:a14="http://schemas.microsoft.com/office/drawing/2010/main" val="0"/>
+              </a:ext>
+            </a:extLst>
+          </a:blip>
+          <a:srcRect/>
+          <a:stretch>
+            <a:fillRect/>
+          </a:stretch>
+        </p:blipFill>
+        <p:spPr bwMode="auto">
+          <a:xfrm>
+            <a:off x="899592" y="1096757"/>
+            <a:ext cx="6481234" cy="5221724"/>
+          </a:xfrm>
+          <a:prstGeom prst="rect">
+            <a:avLst/>
+          </a:prstGeom>
+          <a:noFill/>
+          <a:ln>
+            <a:noFill/>
+          </a:ln>
+          <a:effectLst/>
+          <a:extLst>
+            <a:ext uri="{909E8E84-426E-40DD-AFC4-6F175D3DCCD1}">
+              <a14:hiddenFill xmlns:a14="http://schemas.microsoft.com/office/drawing/2010/main">
+                <a:solidFill>
+                  <a:schemeClr val="accent1"/>
+                </a:solidFill>
+              </a14:hiddenFill>
+            </a:ext>
+            <a:ext uri="{91240B29-F687-4F45-9708-019B960494DF}">
+              <a14:hiddenLine xmlns:a14="http://schemas.microsoft.com/office/drawing/2010/main" w="9525">
+                <a:solidFill>
+                  <a:schemeClr val="tx1"/>
+                </a:solidFill>
+                <a:miter lim="800000"/>
+                <a:headEnd/>
+                <a:tailEnd/>
+              </a14:hiddenLine>
+            </a:ext>
+            <a:ext uri="{AF507438-7753-43E0-B8FC-AC1667EBCBE1}">
+              <a14:hiddenEffects xmlns:a14="http://schemas.microsoft.com/office/drawing/2010/main">
+                <a:effectLst>
+                  <a:outerShdw dist="35921" dir="2700000" algn="ctr" rotWithShape="0">
+                    <a:schemeClr val="bg2"/>
+                  </a:outerShdw>
+                </a:effectLst>
+              </a14:hiddenEffects>
+            </a:ext>
+          </a:extLst>
+        </p:spPr>
+      </p:pic>
+    </p:spTree>
+    <p:extLst>
+      <p:ext uri="{BB962C8B-B14F-4D97-AF65-F5344CB8AC3E}">
+        <p14:creationId xmlns:p14="http://schemas.microsoft.com/office/powerpoint/2010/main" val="424354585"/>
+      </p:ext>
+    </p:extLst>
+  </p:cSld>
+  <p:clrMapOvr>
+    <a:masterClrMapping/>
+  </p:clrMapOvr>
+</p:sld>
+</file>
+
+<file path=ppt/slides/slide15.xml><?xml version="1.0" encoding="utf-8"?>
+<p:sld xmlns:a="http://schemas.openxmlformats.org/drawingml/2006/main" xmlns:r="http://schemas.openxmlformats.org/officeDocument/2006/relationships" xmlns:p="http://schemas.openxmlformats.org/presentationml/2006/main">
+  <p:cSld>
+    <p:spTree>
+      <p:nvGrpSpPr>
+        <p:cNvPr id="1" name=""/>
+        <p:cNvGrpSpPr/>
+        <p:nvPr/>
+      </p:nvGrpSpPr>
+      <p:grpSpPr>
+        <a:xfrm>
+          <a:off x="0" y="0"/>
+          <a:ext cx="0" cy="0"/>
+          <a:chOff x="0" y="0"/>
+          <a:chExt cx="0" cy="0"/>
+        </a:xfrm>
+      </p:grpSpPr>
+      <p:sp>
+        <p:nvSpPr>
+          <p:cNvPr id="2" name="標題 1"/>
+          <p:cNvSpPr>
+            <a:spLocks noGrp="1"/>
+          </p:cNvSpPr>
+          <p:nvPr>
+            <p:ph type="title"/>
+          </p:nvPr>
+        </p:nvSpPr>
+        <p:spPr/>
+        <p:txBody>
+          <a:bodyPr/>
+          <a:lstStyle/>
+          <a:p>
+            <a:endParaRPr lang="zh-TW" altLang="en-US"/>
+          </a:p>
+        </p:txBody>
+      </p:sp>
+      <p:sp>
+        <p:nvSpPr>
+          <p:cNvPr id="3" name="內容版面配置區 2"/>
+          <p:cNvSpPr>
+            <a:spLocks noGrp="1"/>
+          </p:cNvSpPr>
+          <p:nvPr>
+            <p:ph idx="1"/>
+          </p:nvPr>
+        </p:nvSpPr>
+        <p:spPr/>
+        <p:txBody>
+          <a:bodyPr/>
+          <a:lstStyle/>
+          <a:p>
+            <a:endParaRPr lang="zh-TW" altLang="en-US"/>
+          </a:p>
+        </p:txBody>
+      </p:sp>
+      <p:pic>
+        <p:nvPicPr>
+          <p:cNvPr id="11266" name="Picture 2"/>
+          <p:cNvPicPr>
+            <a:picLocks noChangeAspect="1" noChangeArrowheads="1"/>
+          </p:cNvPicPr>
+          <p:nvPr/>
+        </p:nvPicPr>
+        <p:blipFill>
+          <a:blip r:embed="rId2">
+            <a:extLst>
+              <a:ext uri="{28A0092B-C50C-407E-A947-70E740481C1C}">
+                <a14:useLocalDpi xmlns:a14="http://schemas.microsoft.com/office/drawing/2010/main" val="0"/>
+              </a:ext>
+            </a:extLst>
+          </a:blip>
+          <a:srcRect/>
+          <a:stretch>
+            <a:fillRect/>
+          </a:stretch>
+        </p:blipFill>
+        <p:spPr bwMode="auto">
+          <a:xfrm>
+            <a:off x="1043608" y="1268760"/>
+            <a:ext cx="6336704" cy="5108323"/>
+          </a:xfrm>
+          <a:prstGeom prst="rect">
+            <a:avLst/>
+          </a:prstGeom>
+          <a:noFill/>
+          <a:ln>
+            <a:noFill/>
+          </a:ln>
+          <a:effectLst/>
+          <a:extLst>
+            <a:ext uri="{909E8E84-426E-40DD-AFC4-6F175D3DCCD1}">
+              <a14:hiddenFill xmlns:a14="http://schemas.microsoft.com/office/drawing/2010/main">
+                <a:solidFill>
+                  <a:schemeClr val="accent1"/>
+                </a:solidFill>
+              </a14:hiddenFill>
+            </a:ext>
+            <a:ext uri="{91240B29-F687-4F45-9708-019B960494DF}">
+              <a14:hiddenLine xmlns:a14="http://schemas.microsoft.com/office/drawing/2010/main" w="9525">
+                <a:solidFill>
+                  <a:schemeClr val="tx1"/>
+                </a:solidFill>
+                <a:miter lim="800000"/>
+                <a:headEnd/>
+                <a:tailEnd/>
+              </a14:hiddenLine>
+            </a:ext>
+            <a:ext uri="{AF507438-7753-43E0-B8FC-AC1667EBCBE1}">
+              <a14:hiddenEffects xmlns:a14="http://schemas.microsoft.com/office/drawing/2010/main">
+                <a:effectLst>
+                  <a:outerShdw dist="35921" dir="2700000" algn="ctr" rotWithShape="0">
+                    <a:schemeClr val="bg2"/>
+                  </a:outerShdw>
+                </a:effectLst>
+              </a14:hiddenEffects>
+            </a:ext>
+          </a:extLst>
+        </p:spPr>
+      </p:pic>
+    </p:spTree>
+    <p:extLst>
+      <p:ext uri="{BB962C8B-B14F-4D97-AF65-F5344CB8AC3E}">
+        <p14:creationId xmlns:p14="http://schemas.microsoft.com/office/powerpoint/2010/main" val="878978281"/>
+      </p:ext>
+    </p:extLst>
+  </p:cSld>
+  <p:clrMapOvr>
+    <a:masterClrMapping/>
+  </p:clrMapOvr>
+</p:sld>
+</file>
+
+<file path=ppt/slides/slide16.xml><?xml version="1.0" encoding="utf-8"?>
+<p:sld xmlns:a="http://schemas.openxmlformats.org/drawingml/2006/main" xmlns:r="http://schemas.openxmlformats.org/officeDocument/2006/relationships" xmlns:p="http://schemas.openxmlformats.org/presentationml/2006/main">
+  <p:cSld>
+    <p:spTree>
+      <p:nvGrpSpPr>
+        <p:cNvPr id="1" name=""/>
+        <p:cNvGrpSpPr/>
+        <p:nvPr/>
+      </p:nvGrpSpPr>
+      <p:grpSpPr>
+        <a:xfrm>
+          <a:off x="0" y="0"/>
+          <a:ext cx="0" cy="0"/>
+          <a:chOff x="0" y="0"/>
+          <a:chExt cx="0" cy="0"/>
+        </a:xfrm>
+      </p:grpSpPr>
+      <p:sp>
+        <p:nvSpPr>
+          <p:cNvPr id="2" name="標題 1"/>
+          <p:cNvSpPr>
+            <a:spLocks noGrp="1"/>
+          </p:cNvSpPr>
+          <p:nvPr>
+            <p:ph type="title"/>
+          </p:nvPr>
+        </p:nvSpPr>
+        <p:spPr/>
+        <p:txBody>
+          <a:bodyPr/>
+          <a:lstStyle/>
+          <a:p>
+            <a:endParaRPr lang="zh-TW" altLang="en-US"/>
+          </a:p>
+        </p:txBody>
+      </p:sp>
+      <p:pic>
+        <p:nvPicPr>
+          <p:cNvPr id="7" name="Picture 3"/>
+          <p:cNvPicPr>
+            <a:picLocks noGrp="1" noChangeAspect="1" noChangeArrowheads="1"/>
+          </p:cNvPicPr>
+          <p:nvPr>
+            <p:ph idx="1"/>
+          </p:nvPr>
+        </p:nvPicPr>
+        <p:blipFill>
+          <a:blip r:embed="rId2">
+            <a:extLst>
+              <a:ext uri="{28A0092B-C50C-407E-A947-70E740481C1C}">
+                <a14:useLocalDpi xmlns:a14="http://schemas.microsoft.com/office/drawing/2010/main" val="0"/>
+              </a:ext>
+            </a:extLst>
+          </a:blip>
+          <a:srcRect/>
+          <a:stretch>
+            <a:fillRect/>
+          </a:stretch>
+        </p:blipFill>
+        <p:spPr bwMode="auto">
+          <a:xfrm>
+            <a:off x="827584" y="859556"/>
+            <a:ext cx="6565521" cy="5266607"/>
+          </a:xfrm>
+          <a:prstGeom prst="rect">
+            <a:avLst/>
+          </a:prstGeom>
+          <a:noFill/>
+          <a:ln>
+            <a:noFill/>
+          </a:ln>
+          <a:effectLst/>
+          <a:extLst>
+            <a:ext uri="{909E8E84-426E-40DD-AFC4-6F175D3DCCD1}">
+              <a14:hiddenFill xmlns:a14="http://schemas.microsoft.com/office/drawing/2010/main">
+                <a:solidFill>
+                  <a:schemeClr val="accent1"/>
+                </a:solidFill>
+              </a14:hiddenFill>
+            </a:ext>
+            <a:ext uri="{91240B29-F687-4F45-9708-019B960494DF}">
+              <a14:hiddenLine xmlns:a14="http://schemas.microsoft.com/office/drawing/2010/main" w="9525">
+                <a:solidFill>
+                  <a:schemeClr val="tx1"/>
+                </a:solidFill>
+                <a:miter lim="800000"/>
+                <a:headEnd/>
+                <a:tailEnd/>
+              </a14:hiddenLine>
+            </a:ext>
+            <a:ext uri="{AF507438-7753-43E0-B8FC-AC1667EBCBE1}">
+              <a14:hiddenEffects xmlns:a14="http://schemas.microsoft.com/office/drawing/2010/main">
+                <a:effectLst>
+                  <a:outerShdw dist="35921" dir="2700000" algn="ctr" rotWithShape="0">
+                    <a:schemeClr val="bg2"/>
+                  </a:outerShdw>
+                </a:effectLst>
+              </a14:hiddenEffects>
+            </a:ext>
+          </a:extLst>
+        </p:spPr>
+      </p:pic>
+    </p:spTree>
+    <p:extLst>
+      <p:ext uri="{BB962C8B-B14F-4D97-AF65-F5344CB8AC3E}">
+        <p14:creationId xmlns:p14="http://schemas.microsoft.com/office/powerpoint/2010/main" val="1591084412"/>
+      </p:ext>
+    </p:extLst>
+  </p:cSld>
+  <p:clrMapOvr>
+    <a:masterClrMapping/>
+  </p:clrMapOvr>
+</p:sld>
+</file>
+
+<file path=ppt/slides/slide17.xml><?xml version="1.0" encoding="utf-8"?>
+<p:sld xmlns:a="http://schemas.openxmlformats.org/drawingml/2006/main" xmlns:r="http://schemas.openxmlformats.org/officeDocument/2006/relationships" xmlns:p="http://schemas.openxmlformats.org/presentationml/2006/main">
+  <p:cSld>
+    <p:spTree>
+      <p:nvGrpSpPr>
+        <p:cNvPr id="1" name=""/>
+        <p:cNvGrpSpPr/>
+        <p:nvPr/>
+      </p:nvGrpSpPr>
+      <p:grpSpPr>
+        <a:xfrm>
+          <a:off x="0" y="0"/>
+          <a:ext cx="0" cy="0"/>
+          <a:chOff x="0" y="0"/>
+          <a:chExt cx="0" cy="0"/>
+        </a:xfrm>
+      </p:grpSpPr>
+      <p:sp>
+        <p:nvSpPr>
+          <p:cNvPr id="2" name="標題 1"/>
+          <p:cNvSpPr>
+            <a:spLocks noGrp="1"/>
+          </p:cNvSpPr>
+          <p:nvPr>
+            <p:ph type="title"/>
+          </p:nvPr>
+        </p:nvSpPr>
+        <p:spPr/>
+        <p:txBody>
+          <a:bodyPr/>
+          <a:lstStyle/>
+          <a:p>
+            <a:endParaRPr lang="zh-TW" altLang="en-US"/>
+          </a:p>
+        </p:txBody>
+      </p:sp>
+      <p:pic>
+        <p:nvPicPr>
+          <p:cNvPr id="7170" name="Picture 2"/>
+          <p:cNvPicPr>
+            <a:picLocks noGrp="1" noChangeAspect="1" noChangeArrowheads="1"/>
+          </p:cNvPicPr>
+          <p:nvPr>
+            <p:ph idx="1"/>
+          </p:nvPr>
+        </p:nvPicPr>
+        <p:blipFill>
+          <a:blip r:embed="rId2">
+            <a:extLst>
+              <a:ext uri="{28A0092B-C50C-407E-A947-70E740481C1C}">
+                <a14:useLocalDpi xmlns:a14="http://schemas.microsoft.com/office/drawing/2010/main" val="0"/>
+              </a:ext>
+            </a:extLst>
+          </a:blip>
+          <a:srcRect/>
+          <a:stretch>
+            <a:fillRect/>
+          </a:stretch>
+        </p:blipFill>
+        <p:spPr bwMode="auto">
+          <a:xfrm>
+            <a:off x="-27157" y="260648"/>
+            <a:ext cx="6194948" cy="4525963"/>
+          </a:xfrm>
+          <a:prstGeom prst="rect">
+            <a:avLst/>
+          </a:prstGeom>
+          <a:noFill/>
+          <a:ln>
+            <a:noFill/>
+          </a:ln>
+          <a:effectLst/>
+          <a:extLst>
+            <a:ext uri="{909E8E84-426E-40DD-AFC4-6F175D3DCCD1}">
+              <a14:hiddenFill xmlns:a14="http://schemas.microsoft.com/office/drawing/2010/main">
+                <a:solidFill>
+                  <a:schemeClr val="accent1"/>
+                </a:solidFill>
+              </a14:hiddenFill>
+            </a:ext>
+            <a:ext uri="{91240B29-F687-4F45-9708-019B960494DF}">
+              <a14:hiddenLine xmlns:a14="http://schemas.microsoft.com/office/drawing/2010/main" w="9525">
+                <a:solidFill>
+                  <a:schemeClr val="tx1"/>
+                </a:solidFill>
+                <a:miter lim="800000"/>
+                <a:headEnd/>
+                <a:tailEnd/>
+              </a14:hiddenLine>
+            </a:ext>
+            <a:ext uri="{AF507438-7753-43E0-B8FC-AC1667EBCBE1}">
+              <a14:hiddenEffects xmlns:a14="http://schemas.microsoft.com/office/drawing/2010/main">
+                <a:effectLst>
+                  <a:outerShdw dist="35921" dir="2700000" algn="ctr" rotWithShape="0">
+                    <a:schemeClr val="bg2"/>
+                  </a:outerShdw>
+                </a:effectLst>
+              </a14:hiddenEffects>
+            </a:ext>
+          </a:extLst>
+        </p:spPr>
+      </p:pic>
+      <p:pic>
+        <p:nvPicPr>
+          <p:cNvPr id="7171" name="Picture 3"/>
+          <p:cNvPicPr>
+            <a:picLocks noChangeAspect="1" noChangeArrowheads="1"/>
+          </p:cNvPicPr>
+          <p:nvPr/>
+        </p:nvPicPr>
+        <p:blipFill>
+          <a:blip r:embed="rId3">
+            <a:extLst>
+              <a:ext uri="{28A0092B-C50C-407E-A947-70E740481C1C}">
+                <a14:useLocalDpi xmlns:a14="http://schemas.microsoft.com/office/drawing/2010/main" val="0"/>
+              </a:ext>
+            </a:extLst>
+          </a:blip>
+          <a:srcRect/>
+          <a:stretch>
+            <a:fillRect/>
+          </a:stretch>
+        </p:blipFill>
+        <p:spPr bwMode="auto">
+          <a:xfrm>
+            <a:off x="3320567" y="2204864"/>
+            <a:ext cx="5823433" cy="4230068"/>
+          </a:xfrm>
+          <a:prstGeom prst="rect">
+            <a:avLst/>
+          </a:prstGeom>
+          <a:noFill/>
+          <a:ln>
+            <a:noFill/>
+          </a:ln>
+          <a:effectLst/>
+          <a:extLst>
+            <a:ext uri="{909E8E84-426E-40DD-AFC4-6F175D3DCCD1}">
+              <a14:hiddenFill xmlns:a14="http://schemas.microsoft.com/office/drawing/2010/main">
+                <a:solidFill>
+                  <a:schemeClr val="accent1"/>
+                </a:solidFill>
+              </a14:hiddenFill>
+            </a:ext>
+            <a:ext uri="{91240B29-F687-4F45-9708-019B960494DF}">
+              <a14:hiddenLine xmlns:a14="http://schemas.microsoft.com/office/drawing/2010/main" w="9525">
+                <a:solidFill>
+                  <a:schemeClr val="tx1"/>
+                </a:solidFill>
+                <a:miter lim="800000"/>
+                <a:headEnd/>
+                <a:tailEnd/>
+              </a14:hiddenLine>
+            </a:ext>
+            <a:ext uri="{AF507438-7753-43E0-B8FC-AC1667EBCBE1}">
+              <a14:hiddenEffects xmlns:a14="http://schemas.microsoft.com/office/drawing/2010/main">
+                <a:effectLst>
+                  <a:outerShdw dist="35921" dir="2700000" algn="ctr" rotWithShape="0">
+                    <a:schemeClr val="bg2"/>
+                  </a:outerShdw>
+                </a:effectLst>
+              </a14:hiddenEffects>
+            </a:ext>
+          </a:extLst>
+        </p:spPr>
+      </p:pic>
+      <p:sp>
+        <p:nvSpPr>
+          <p:cNvPr id="6" name="文字方塊 5"/>
+          <p:cNvSpPr txBox="1"/>
+          <p:nvPr/>
+        </p:nvSpPr>
+        <p:spPr>
+          <a:xfrm>
+            <a:off x="1115616" y="5229200"/>
+            <a:ext cx="1010213" cy="369332"/>
+          </a:xfrm>
+          <a:prstGeom prst="rect">
+            <a:avLst/>
+          </a:prstGeom>
+          <a:noFill/>
+        </p:spPr>
+        <p:txBody>
+          <a:bodyPr wrap="none" rtlCol="0">
+            <a:spAutoFit/>
+          </a:bodyPr>
+          <a:lstStyle/>
+          <a:p>
+            <a:r>
+              <a:rPr lang="en-US" altLang="zh-TW" dirty="0" smtClean="0"/>
+              <a:t>200</a:t>
+            </a:r>
+            <a:r>
+              <a:rPr lang="zh-TW" altLang="en-US" dirty="0" smtClean="0"/>
+              <a:t> </a:t>
+            </a:r>
+            <a:r>
+              <a:rPr lang="en-US" altLang="zh-TW" dirty="0" smtClean="0"/>
+              <a:t>-230</a:t>
+            </a:r>
+            <a:endParaRPr lang="zh-TW" altLang="en-US" dirty="0"/>
+          </a:p>
+        </p:txBody>
+      </p:sp>
+    </p:spTree>
+    <p:extLst>
+      <p:ext uri="{BB962C8B-B14F-4D97-AF65-F5344CB8AC3E}">
+        <p14:creationId xmlns:p14="http://schemas.microsoft.com/office/powerpoint/2010/main" val="1288609883"/>
+      </p:ext>
+    </p:extLst>
+  </p:cSld>
+  <p:clrMapOvr>
+    <a:masterClrMapping/>
+  </p:clrMapOvr>
+</p:sld>
+</file>
+
+<file path=ppt/slides/slide18.xml><?xml version="1.0" encoding="utf-8"?>
+<p:sld xmlns:a="http://schemas.openxmlformats.org/drawingml/2006/main" xmlns:r="http://schemas.openxmlformats.org/officeDocument/2006/relationships" xmlns:p="http://schemas.openxmlformats.org/presentationml/2006/main">
+  <p:cSld>
+    <p:spTree>
+      <p:nvGrpSpPr>
+        <p:cNvPr id="1" name=""/>
+        <p:cNvGrpSpPr/>
+        <p:nvPr/>
+      </p:nvGrpSpPr>
+      <p:grpSpPr>
+        <a:xfrm>
+          <a:off x="0" y="0"/>
+          <a:ext cx="0" cy="0"/>
+          <a:chOff x="0" y="0"/>
+          <a:chExt cx="0" cy="0"/>
+        </a:xfrm>
+      </p:grpSpPr>
+      <p:sp>
+        <p:nvSpPr>
+          <p:cNvPr id="2" name="標題 1"/>
+          <p:cNvSpPr>
+            <a:spLocks noGrp="1"/>
+          </p:cNvSpPr>
+          <p:nvPr>
+            <p:ph type="title"/>
+          </p:nvPr>
+        </p:nvSpPr>
+        <p:spPr/>
+        <p:txBody>
+          <a:bodyPr/>
+          <a:lstStyle/>
+          <a:p>
+            <a:endParaRPr lang="zh-TW" altLang="en-US"/>
+          </a:p>
+        </p:txBody>
+      </p:sp>
+      <p:pic>
+        <p:nvPicPr>
+          <p:cNvPr id="5" name="Picture 2"/>
+          <p:cNvPicPr>
+            <a:picLocks noGrp="1" noChangeAspect="1" noChangeArrowheads="1"/>
+          </p:cNvPicPr>
+          <p:nvPr>
+            <p:ph idx="1"/>
+          </p:nvPr>
+        </p:nvPicPr>
+        <p:blipFill>
+          <a:blip r:embed="rId2">
+            <a:extLst>
+              <a:ext uri="{28A0092B-C50C-407E-A947-70E740481C1C}">
+                <a14:useLocalDpi xmlns:a14="http://schemas.microsoft.com/office/drawing/2010/main" val="0"/>
+              </a:ext>
+            </a:extLst>
+          </a:blip>
+          <a:srcRect/>
+          <a:stretch>
+            <a:fillRect/>
+          </a:stretch>
+        </p:blipFill>
+        <p:spPr bwMode="auto">
+          <a:xfrm>
+            <a:off x="539552" y="561422"/>
+            <a:ext cx="6796233" cy="5564741"/>
+          </a:xfrm>
+          <a:prstGeom prst="rect">
+            <a:avLst/>
+          </a:prstGeom>
+          <a:noFill/>
+          <a:ln>
+            <a:noFill/>
+          </a:ln>
+          <a:effectLst/>
+          <a:extLst>
+            <a:ext uri="{909E8E84-426E-40DD-AFC4-6F175D3DCCD1}">
+              <a14:hiddenFill xmlns:a14="http://schemas.microsoft.com/office/drawing/2010/main">
+                <a:solidFill>
+                  <a:schemeClr val="accent1"/>
+                </a:solidFill>
+              </a14:hiddenFill>
+            </a:ext>
+            <a:ext uri="{91240B29-F687-4F45-9708-019B960494DF}">
+              <a14:hiddenLine xmlns:a14="http://schemas.microsoft.com/office/drawing/2010/main" w="9525">
+                <a:solidFill>
+                  <a:schemeClr val="tx1"/>
+                </a:solidFill>
+                <a:miter lim="800000"/>
+                <a:headEnd/>
+                <a:tailEnd/>
+              </a14:hiddenLine>
+            </a:ext>
+            <a:ext uri="{AF507438-7753-43E0-B8FC-AC1667EBCBE1}">
+              <a14:hiddenEffects xmlns:a14="http://schemas.microsoft.com/office/drawing/2010/main">
+                <a:effectLst>
+                  <a:outerShdw dist="35921" dir="2700000" algn="ctr" rotWithShape="0">
+                    <a:schemeClr val="bg2"/>
+                  </a:outerShdw>
+                </a:effectLst>
+              </a14:hiddenEffects>
+            </a:ext>
+          </a:extLst>
+        </p:spPr>
+      </p:pic>
+    </p:spTree>
+    <p:extLst>
+      <p:ext uri="{BB962C8B-B14F-4D97-AF65-F5344CB8AC3E}">
+        <p14:creationId xmlns:p14="http://schemas.microsoft.com/office/powerpoint/2010/main" val="1977172275"/>
+      </p:ext>
+    </p:extLst>
+  </p:cSld>
+  <p:clrMapOvr>
+    <a:masterClrMapping/>
+  </p:clrMapOvr>
+</p:sld>
+</file>
+
+<file path=ppt/slides/slide19.xml><?xml version="1.0" encoding="utf-8"?>
+<p:sld xmlns:a="http://schemas.openxmlformats.org/drawingml/2006/main" xmlns:r="http://schemas.openxmlformats.org/officeDocument/2006/relationships" xmlns:p="http://schemas.openxmlformats.org/presentationml/2006/main">
+  <p:cSld>
+    <p:spTree>
+      <p:nvGrpSpPr>
+        <p:cNvPr id="1" name=""/>
+        <p:cNvGrpSpPr/>
+        <p:nvPr/>
+      </p:nvGrpSpPr>
+      <p:grpSpPr>
+        <a:xfrm>
+          <a:off x="0" y="0"/>
+          <a:ext cx="0" cy="0"/>
+          <a:chOff x="0" y="0"/>
+          <a:chExt cx="0" cy="0"/>
+        </a:xfrm>
+      </p:grpSpPr>
+      <p:sp>
+        <p:nvSpPr>
+          <p:cNvPr id="2" name="標題 1"/>
+          <p:cNvSpPr>
+            <a:spLocks noGrp="1"/>
+          </p:cNvSpPr>
+          <p:nvPr>
+            <p:ph type="title"/>
+          </p:nvPr>
+        </p:nvSpPr>
+        <p:spPr/>
+        <p:txBody>
+          <a:bodyPr/>
+          <a:lstStyle/>
+          <a:p>
+            <a:endParaRPr lang="zh-TW" altLang="en-US"/>
+          </a:p>
+        </p:txBody>
+      </p:sp>
+      <p:pic>
+        <p:nvPicPr>
+          <p:cNvPr id="6147" name="Picture 3"/>
+          <p:cNvPicPr>
+            <a:picLocks noChangeAspect="1" noChangeArrowheads="1"/>
+          </p:cNvPicPr>
+          <p:nvPr/>
+        </p:nvPicPr>
+        <p:blipFill>
+          <a:blip r:embed="rId2">
+            <a:extLst>
+              <a:ext uri="{28A0092B-C50C-407E-A947-70E740481C1C}">
+                <a14:useLocalDpi xmlns:a14="http://schemas.microsoft.com/office/drawing/2010/main" val="0"/>
+              </a:ext>
+            </a:extLst>
+          </a:blip>
+          <a:srcRect/>
+          <a:stretch>
+            <a:fillRect/>
+          </a:stretch>
+        </p:blipFill>
+        <p:spPr bwMode="auto">
+          <a:xfrm>
+            <a:off x="0" y="260648"/>
+            <a:ext cx="5947112" cy="4464496"/>
+          </a:xfrm>
+          <a:prstGeom prst="rect">
+            <a:avLst/>
+          </a:prstGeom>
+          <a:noFill/>
+          <a:ln>
+            <a:noFill/>
+          </a:ln>
+          <a:effectLst/>
+          <a:extLst>
+            <a:ext uri="{909E8E84-426E-40DD-AFC4-6F175D3DCCD1}">
+              <a14:hiddenFill xmlns:a14="http://schemas.microsoft.com/office/drawing/2010/main">
+                <a:solidFill>
+                  <a:schemeClr val="accent1"/>
+                </a:solidFill>
+              </a14:hiddenFill>
+            </a:ext>
+            <a:ext uri="{91240B29-F687-4F45-9708-019B960494DF}">
+              <a14:hiddenLine xmlns:a14="http://schemas.microsoft.com/office/drawing/2010/main" w="9525">
+                <a:solidFill>
+                  <a:schemeClr val="tx1"/>
+                </a:solidFill>
+                <a:miter lim="800000"/>
+                <a:headEnd/>
+                <a:tailEnd/>
+              </a14:hiddenLine>
+            </a:ext>
+            <a:ext uri="{AF507438-7753-43E0-B8FC-AC1667EBCBE1}">
+              <a14:hiddenEffects xmlns:a14="http://schemas.microsoft.com/office/drawing/2010/main">
+                <a:effectLst>
+                  <a:outerShdw dist="35921" dir="2700000" algn="ctr" rotWithShape="0">
+                    <a:schemeClr val="bg2"/>
+                  </a:outerShdw>
+                </a:effectLst>
+              </a14:hiddenEffects>
+            </a:ext>
+          </a:extLst>
+        </p:spPr>
+      </p:pic>
+      <p:pic>
+        <p:nvPicPr>
+          <p:cNvPr id="6146" name="Picture 2"/>
+          <p:cNvPicPr>
+            <a:picLocks noGrp="1" noChangeAspect="1" noChangeArrowheads="1"/>
+          </p:cNvPicPr>
+          <p:nvPr>
+            <p:ph idx="1"/>
+          </p:nvPr>
+        </p:nvPicPr>
+        <p:blipFill>
+          <a:blip r:embed="rId3">
+            <a:extLst>
+              <a:ext uri="{28A0092B-C50C-407E-A947-70E740481C1C}">
+                <a14:useLocalDpi xmlns:a14="http://schemas.microsoft.com/office/drawing/2010/main" val="0"/>
+              </a:ext>
+            </a:extLst>
+          </a:blip>
+          <a:srcRect/>
+          <a:stretch>
+            <a:fillRect/>
+          </a:stretch>
+        </p:blipFill>
+        <p:spPr bwMode="auto">
+          <a:xfrm>
+            <a:off x="3563888" y="1556792"/>
+            <a:ext cx="5675413" cy="4525963"/>
+          </a:xfrm>
+          <a:prstGeom prst="rect">
+            <a:avLst/>
+          </a:prstGeom>
+          <a:noFill/>
+          <a:ln>
+            <a:noFill/>
+          </a:ln>
+          <a:effectLst/>
+          <a:extLst>
+            <a:ext uri="{909E8E84-426E-40DD-AFC4-6F175D3DCCD1}">
+              <a14:hiddenFill xmlns:a14="http://schemas.microsoft.com/office/drawing/2010/main">
+                <a:solidFill>
+                  <a:schemeClr val="accent1"/>
+                </a:solidFill>
+              </a14:hiddenFill>
+            </a:ext>
+            <a:ext uri="{91240B29-F687-4F45-9708-019B960494DF}">
+              <a14:hiddenLine xmlns:a14="http://schemas.microsoft.com/office/drawing/2010/main" w="9525">
+                <a:solidFill>
+                  <a:schemeClr val="tx1"/>
+                </a:solidFill>
+                <a:miter lim="800000"/>
+                <a:headEnd/>
+                <a:tailEnd/>
+              </a14:hiddenLine>
+            </a:ext>
+            <a:ext uri="{AF507438-7753-43E0-B8FC-AC1667EBCBE1}">
+              <a14:hiddenEffects xmlns:a14="http://schemas.microsoft.com/office/drawing/2010/main">
+                <a:effectLst>
+                  <a:outerShdw dist="35921" dir="2700000" algn="ctr" rotWithShape="0">
+                    <a:schemeClr val="bg2"/>
+                  </a:outerShdw>
+                </a:effectLst>
+              </a14:hiddenEffects>
+            </a:ext>
+          </a:extLst>
+        </p:spPr>
+      </p:pic>
+      <p:sp>
+        <p:nvSpPr>
+          <p:cNvPr id="4" name="文字方塊 3"/>
+          <p:cNvSpPr txBox="1"/>
+          <p:nvPr/>
+        </p:nvSpPr>
+        <p:spPr>
+          <a:xfrm>
+            <a:off x="1115616" y="5229200"/>
+            <a:ext cx="1010213" cy="369332"/>
+          </a:xfrm>
+          <a:prstGeom prst="rect">
+            <a:avLst/>
+          </a:prstGeom>
+          <a:noFill/>
+        </p:spPr>
+        <p:txBody>
+          <a:bodyPr wrap="none" rtlCol="0">
+            <a:spAutoFit/>
+          </a:bodyPr>
+          <a:lstStyle/>
+          <a:p>
+            <a:r>
+              <a:rPr lang="en-US" altLang="zh-TW" dirty="0" smtClean="0"/>
+              <a:t>200</a:t>
+            </a:r>
+            <a:r>
+              <a:rPr lang="zh-TW" altLang="en-US" dirty="0" smtClean="0"/>
+              <a:t> </a:t>
+            </a:r>
+            <a:r>
+              <a:rPr lang="en-US" altLang="zh-TW" dirty="0" smtClean="0"/>
+              <a:t>-230</a:t>
+            </a:r>
+            <a:endParaRPr lang="zh-TW" altLang="en-US" dirty="0"/>
+          </a:p>
+        </p:txBody>
+      </p:sp>
+    </p:spTree>
+    <p:extLst>
+      <p:ext uri="{BB962C8B-B14F-4D97-AF65-F5344CB8AC3E}">
+        <p14:creationId xmlns:p14="http://schemas.microsoft.com/office/powerpoint/2010/main" val="1616979130"/>
+      </p:ext>
+    </p:extLst>
+  </p:cSld>
+  <p:clrMapOvr>
+    <a:masterClrMapping/>
+  </p:clrMapOvr>
+</p:sld>
+</file>
+
 <file path=ppt/slides/slide2.xml><?xml version="1.0" encoding="utf-8"?>
 <p:sld xmlns:a="http://schemas.openxmlformats.org/drawingml/2006/main" xmlns:r="http://schemas.openxmlformats.org/officeDocument/2006/relationships" xmlns:p="http://schemas.openxmlformats.org/presentationml/2006/main">
   <p:cSld>
@@ -3292,6 +4686,1358 @@
     <p:extLst>
       <p:ext uri="{BB962C8B-B14F-4D97-AF65-F5344CB8AC3E}">
         <p14:creationId xmlns:p14="http://schemas.microsoft.com/office/powerpoint/2010/main" val="3955712228"/>
+      </p:ext>
+    </p:extLst>
+  </p:cSld>
+  <p:clrMapOvr>
+    <a:masterClrMapping/>
+  </p:clrMapOvr>
+</p:sld>
+</file>
+
+<file path=ppt/slides/slide20.xml><?xml version="1.0" encoding="utf-8"?>
+<p:sld xmlns:a="http://schemas.openxmlformats.org/drawingml/2006/main" xmlns:r="http://schemas.openxmlformats.org/officeDocument/2006/relationships" xmlns:p="http://schemas.openxmlformats.org/presentationml/2006/main">
+  <p:cSld>
+    <p:spTree>
+      <p:nvGrpSpPr>
+        <p:cNvPr id="1" name=""/>
+        <p:cNvGrpSpPr/>
+        <p:nvPr/>
+      </p:nvGrpSpPr>
+      <p:grpSpPr>
+        <a:xfrm>
+          <a:off x="0" y="0"/>
+          <a:ext cx="0" cy="0"/>
+          <a:chOff x="0" y="0"/>
+          <a:chExt cx="0" cy="0"/>
+        </a:xfrm>
+      </p:grpSpPr>
+      <p:sp>
+        <p:nvSpPr>
+          <p:cNvPr id="2" name="標題 1"/>
+          <p:cNvSpPr>
+            <a:spLocks noGrp="1"/>
+          </p:cNvSpPr>
+          <p:nvPr>
+            <p:ph type="title"/>
+          </p:nvPr>
+        </p:nvSpPr>
+        <p:spPr/>
+        <p:txBody>
+          <a:bodyPr/>
+          <a:lstStyle/>
+          <a:p>
+            <a:endParaRPr lang="zh-TW" altLang="en-US"/>
+          </a:p>
+        </p:txBody>
+      </p:sp>
+      <p:pic>
+        <p:nvPicPr>
+          <p:cNvPr id="5" name="Picture 2"/>
+          <p:cNvPicPr>
+            <a:picLocks noGrp="1" noChangeAspect="1" noChangeArrowheads="1"/>
+          </p:cNvPicPr>
+          <p:nvPr>
+            <p:ph idx="1"/>
+          </p:nvPr>
+        </p:nvPicPr>
+        <p:blipFill>
+          <a:blip r:embed="rId2">
+            <a:extLst>
+              <a:ext uri="{28A0092B-C50C-407E-A947-70E740481C1C}">
+                <a14:useLocalDpi xmlns:a14="http://schemas.microsoft.com/office/drawing/2010/main" val="0"/>
+              </a:ext>
+            </a:extLst>
+          </a:blip>
+          <a:srcRect/>
+          <a:stretch>
+            <a:fillRect/>
+          </a:stretch>
+        </p:blipFill>
+        <p:spPr bwMode="auto">
+          <a:xfrm>
+            <a:off x="597415" y="980728"/>
+            <a:ext cx="6779078" cy="5470127"/>
+          </a:xfrm>
+          <a:prstGeom prst="rect">
+            <a:avLst/>
+          </a:prstGeom>
+          <a:noFill/>
+          <a:ln>
+            <a:noFill/>
+          </a:ln>
+          <a:effectLst/>
+          <a:extLst>
+            <a:ext uri="{909E8E84-426E-40DD-AFC4-6F175D3DCCD1}">
+              <a14:hiddenFill xmlns:a14="http://schemas.microsoft.com/office/drawing/2010/main">
+                <a:solidFill>
+                  <a:schemeClr val="accent1"/>
+                </a:solidFill>
+              </a14:hiddenFill>
+            </a:ext>
+            <a:ext uri="{91240B29-F687-4F45-9708-019B960494DF}">
+              <a14:hiddenLine xmlns:a14="http://schemas.microsoft.com/office/drawing/2010/main" w="9525">
+                <a:solidFill>
+                  <a:schemeClr val="tx1"/>
+                </a:solidFill>
+                <a:miter lim="800000"/>
+                <a:headEnd/>
+                <a:tailEnd/>
+              </a14:hiddenLine>
+            </a:ext>
+            <a:ext uri="{AF507438-7753-43E0-B8FC-AC1667EBCBE1}">
+              <a14:hiddenEffects xmlns:a14="http://schemas.microsoft.com/office/drawing/2010/main">
+                <a:effectLst>
+                  <a:outerShdw dist="35921" dir="2700000" algn="ctr" rotWithShape="0">
+                    <a:schemeClr val="bg2"/>
+                  </a:outerShdw>
+                </a:effectLst>
+              </a14:hiddenEffects>
+            </a:ext>
+          </a:extLst>
+        </p:spPr>
+      </p:pic>
+    </p:spTree>
+    <p:extLst>
+      <p:ext uri="{BB962C8B-B14F-4D97-AF65-F5344CB8AC3E}">
+        <p14:creationId xmlns:p14="http://schemas.microsoft.com/office/powerpoint/2010/main" val="2975016543"/>
+      </p:ext>
+    </p:extLst>
+  </p:cSld>
+  <p:clrMapOvr>
+    <a:masterClrMapping/>
+  </p:clrMapOvr>
+</p:sld>
+</file>
+
+<file path=ppt/slides/slide21.xml><?xml version="1.0" encoding="utf-8"?>
+<p:sld xmlns:a="http://schemas.openxmlformats.org/drawingml/2006/main" xmlns:r="http://schemas.openxmlformats.org/officeDocument/2006/relationships" xmlns:p="http://schemas.openxmlformats.org/presentationml/2006/main">
+  <p:cSld>
+    <p:spTree>
+      <p:nvGrpSpPr>
+        <p:cNvPr id="1" name=""/>
+        <p:cNvGrpSpPr/>
+        <p:nvPr/>
+      </p:nvGrpSpPr>
+      <p:grpSpPr>
+        <a:xfrm>
+          <a:off x="0" y="0"/>
+          <a:ext cx="0" cy="0"/>
+          <a:chOff x="0" y="0"/>
+          <a:chExt cx="0" cy="0"/>
+        </a:xfrm>
+      </p:grpSpPr>
+      <p:sp>
+        <p:nvSpPr>
+          <p:cNvPr id="2" name="標題 1"/>
+          <p:cNvSpPr>
+            <a:spLocks noGrp="1"/>
+          </p:cNvSpPr>
+          <p:nvPr>
+            <p:ph type="title"/>
+          </p:nvPr>
+        </p:nvSpPr>
+        <p:spPr/>
+        <p:txBody>
+          <a:bodyPr/>
+          <a:lstStyle/>
+          <a:p>
+            <a:endParaRPr lang="zh-TW" altLang="en-US"/>
+          </a:p>
+        </p:txBody>
+      </p:sp>
+      <p:pic>
+        <p:nvPicPr>
+          <p:cNvPr id="5" name="Picture 2"/>
+          <p:cNvPicPr>
+            <a:picLocks noGrp="1" noChangeAspect="1" noChangeArrowheads="1"/>
+          </p:cNvPicPr>
+          <p:nvPr>
+            <p:ph idx="1"/>
+          </p:nvPr>
+        </p:nvPicPr>
+        <p:blipFill>
+          <a:blip r:embed="rId2">
+            <a:extLst>
+              <a:ext uri="{28A0092B-C50C-407E-A947-70E740481C1C}">
+                <a14:useLocalDpi xmlns:a14="http://schemas.microsoft.com/office/drawing/2010/main" val="0"/>
+              </a:ext>
+            </a:extLst>
+          </a:blip>
+          <a:srcRect/>
+          <a:stretch>
+            <a:fillRect/>
+          </a:stretch>
+        </p:blipFill>
+        <p:spPr bwMode="auto">
+          <a:xfrm>
+            <a:off x="611560" y="889250"/>
+            <a:ext cx="6612908" cy="5409529"/>
+          </a:xfrm>
+          <a:prstGeom prst="rect">
+            <a:avLst/>
+          </a:prstGeom>
+          <a:noFill/>
+          <a:ln>
+            <a:noFill/>
+          </a:ln>
+          <a:effectLst/>
+          <a:extLst>
+            <a:ext uri="{909E8E84-426E-40DD-AFC4-6F175D3DCCD1}">
+              <a14:hiddenFill xmlns:a14="http://schemas.microsoft.com/office/drawing/2010/main">
+                <a:solidFill>
+                  <a:schemeClr val="accent1"/>
+                </a:solidFill>
+              </a14:hiddenFill>
+            </a:ext>
+            <a:ext uri="{91240B29-F687-4F45-9708-019B960494DF}">
+              <a14:hiddenLine xmlns:a14="http://schemas.microsoft.com/office/drawing/2010/main" w="9525">
+                <a:solidFill>
+                  <a:schemeClr val="tx1"/>
+                </a:solidFill>
+                <a:miter lim="800000"/>
+                <a:headEnd/>
+                <a:tailEnd/>
+              </a14:hiddenLine>
+            </a:ext>
+            <a:ext uri="{AF507438-7753-43E0-B8FC-AC1667EBCBE1}">
+              <a14:hiddenEffects xmlns:a14="http://schemas.microsoft.com/office/drawing/2010/main">
+                <a:effectLst>
+                  <a:outerShdw dist="35921" dir="2700000" algn="ctr" rotWithShape="0">
+                    <a:schemeClr val="bg2"/>
+                  </a:outerShdw>
+                </a:effectLst>
+              </a14:hiddenEffects>
+            </a:ext>
+          </a:extLst>
+        </p:spPr>
+      </p:pic>
+    </p:spTree>
+    <p:extLst>
+      <p:ext uri="{BB962C8B-B14F-4D97-AF65-F5344CB8AC3E}">
+        <p14:creationId xmlns:p14="http://schemas.microsoft.com/office/powerpoint/2010/main" val="2926895504"/>
+      </p:ext>
+    </p:extLst>
+  </p:cSld>
+  <p:clrMapOvr>
+    <a:masterClrMapping/>
+  </p:clrMapOvr>
+</p:sld>
+</file>
+
+<file path=ppt/slides/slide22.xml><?xml version="1.0" encoding="utf-8"?>
+<p:sld xmlns:a="http://schemas.openxmlformats.org/drawingml/2006/main" xmlns:r="http://schemas.openxmlformats.org/officeDocument/2006/relationships" xmlns:p="http://schemas.openxmlformats.org/presentationml/2006/main">
+  <p:cSld>
+    <p:spTree>
+      <p:nvGrpSpPr>
+        <p:cNvPr id="1" name=""/>
+        <p:cNvGrpSpPr/>
+        <p:nvPr/>
+      </p:nvGrpSpPr>
+      <p:grpSpPr>
+        <a:xfrm>
+          <a:off x="0" y="0"/>
+          <a:ext cx="0" cy="0"/>
+          <a:chOff x="0" y="0"/>
+          <a:chExt cx="0" cy="0"/>
+        </a:xfrm>
+      </p:grpSpPr>
+      <p:sp>
+        <p:nvSpPr>
+          <p:cNvPr id="2" name="標題 1"/>
+          <p:cNvSpPr>
+            <a:spLocks noGrp="1"/>
+          </p:cNvSpPr>
+          <p:nvPr>
+            <p:ph type="title"/>
+          </p:nvPr>
+        </p:nvSpPr>
+        <p:spPr/>
+        <p:txBody>
+          <a:bodyPr/>
+          <a:lstStyle/>
+          <a:p>
+            <a:endParaRPr lang="zh-TW" altLang="en-US"/>
+          </a:p>
+        </p:txBody>
+      </p:sp>
+      <p:pic>
+        <p:nvPicPr>
+          <p:cNvPr id="9219" name="Picture 3"/>
+          <p:cNvPicPr>
+            <a:picLocks noChangeAspect="1" noChangeArrowheads="1"/>
+          </p:cNvPicPr>
+          <p:nvPr/>
+        </p:nvPicPr>
+        <p:blipFill>
+          <a:blip r:embed="rId2">
+            <a:extLst>
+              <a:ext uri="{28A0092B-C50C-407E-A947-70E740481C1C}">
+                <a14:useLocalDpi xmlns:a14="http://schemas.microsoft.com/office/drawing/2010/main" val="0"/>
+              </a:ext>
+            </a:extLst>
+          </a:blip>
+          <a:srcRect/>
+          <a:stretch>
+            <a:fillRect/>
+          </a:stretch>
+        </p:blipFill>
+        <p:spPr bwMode="auto">
+          <a:xfrm>
+            <a:off x="3231684" y="260648"/>
+            <a:ext cx="6032017" cy="4543380"/>
+          </a:xfrm>
+          <a:prstGeom prst="rect">
+            <a:avLst/>
+          </a:prstGeom>
+          <a:noFill/>
+          <a:ln>
+            <a:noFill/>
+          </a:ln>
+          <a:effectLst/>
+          <a:extLst>
+            <a:ext uri="{909E8E84-426E-40DD-AFC4-6F175D3DCCD1}">
+              <a14:hiddenFill xmlns:a14="http://schemas.microsoft.com/office/drawing/2010/main">
+                <a:solidFill>
+                  <a:schemeClr val="accent1"/>
+                </a:solidFill>
+              </a14:hiddenFill>
+            </a:ext>
+            <a:ext uri="{91240B29-F687-4F45-9708-019B960494DF}">
+              <a14:hiddenLine xmlns:a14="http://schemas.microsoft.com/office/drawing/2010/main" w="9525">
+                <a:solidFill>
+                  <a:schemeClr val="tx1"/>
+                </a:solidFill>
+                <a:miter lim="800000"/>
+                <a:headEnd/>
+                <a:tailEnd/>
+              </a14:hiddenLine>
+            </a:ext>
+            <a:ext uri="{AF507438-7753-43E0-B8FC-AC1667EBCBE1}">
+              <a14:hiddenEffects xmlns:a14="http://schemas.microsoft.com/office/drawing/2010/main">
+                <a:effectLst>
+                  <a:outerShdw dist="35921" dir="2700000" algn="ctr" rotWithShape="0">
+                    <a:schemeClr val="bg2"/>
+                  </a:outerShdw>
+                </a:effectLst>
+              </a14:hiddenEffects>
+            </a:ext>
+          </a:extLst>
+        </p:spPr>
+      </p:pic>
+      <p:pic>
+        <p:nvPicPr>
+          <p:cNvPr id="9218" name="Picture 2"/>
+          <p:cNvPicPr>
+            <a:picLocks noChangeAspect="1" noChangeArrowheads="1"/>
+          </p:cNvPicPr>
+          <p:nvPr/>
+        </p:nvPicPr>
+        <p:blipFill>
+          <a:blip r:embed="rId3">
+            <a:extLst>
+              <a:ext uri="{28A0092B-C50C-407E-A947-70E740481C1C}">
+                <a14:useLocalDpi xmlns:a14="http://schemas.microsoft.com/office/drawing/2010/main" val="0"/>
+              </a:ext>
+            </a:extLst>
+          </a:blip>
+          <a:srcRect/>
+          <a:stretch>
+            <a:fillRect/>
+          </a:stretch>
+        </p:blipFill>
+        <p:spPr bwMode="auto">
+          <a:xfrm>
+            <a:off x="0" y="2060848"/>
+            <a:ext cx="5799078" cy="4400278"/>
+          </a:xfrm>
+          <a:prstGeom prst="rect">
+            <a:avLst/>
+          </a:prstGeom>
+          <a:noFill/>
+          <a:ln>
+            <a:noFill/>
+          </a:ln>
+          <a:effectLst/>
+          <a:extLst>
+            <a:ext uri="{909E8E84-426E-40DD-AFC4-6F175D3DCCD1}">
+              <a14:hiddenFill xmlns:a14="http://schemas.microsoft.com/office/drawing/2010/main">
+                <a:solidFill>
+                  <a:schemeClr val="accent1"/>
+                </a:solidFill>
+              </a14:hiddenFill>
+            </a:ext>
+            <a:ext uri="{91240B29-F687-4F45-9708-019B960494DF}">
+              <a14:hiddenLine xmlns:a14="http://schemas.microsoft.com/office/drawing/2010/main" w="9525">
+                <a:solidFill>
+                  <a:schemeClr val="tx1"/>
+                </a:solidFill>
+                <a:miter lim="800000"/>
+                <a:headEnd/>
+                <a:tailEnd/>
+              </a14:hiddenLine>
+            </a:ext>
+            <a:ext uri="{AF507438-7753-43E0-B8FC-AC1667EBCBE1}">
+              <a14:hiddenEffects xmlns:a14="http://schemas.microsoft.com/office/drawing/2010/main">
+                <a:effectLst>
+                  <a:outerShdw dist="35921" dir="2700000" algn="ctr" rotWithShape="0">
+                    <a:schemeClr val="bg2"/>
+                  </a:outerShdw>
+                </a:effectLst>
+              </a14:hiddenEffects>
+            </a:ext>
+          </a:extLst>
+        </p:spPr>
+      </p:pic>
+      <p:sp>
+        <p:nvSpPr>
+          <p:cNvPr id="6" name="文字方塊 5"/>
+          <p:cNvSpPr txBox="1"/>
+          <p:nvPr/>
+        </p:nvSpPr>
+        <p:spPr>
+          <a:xfrm>
+            <a:off x="611560" y="1844824"/>
+            <a:ext cx="1010213" cy="369332"/>
+          </a:xfrm>
+          <a:prstGeom prst="rect">
+            <a:avLst/>
+          </a:prstGeom>
+          <a:noFill/>
+        </p:spPr>
+        <p:txBody>
+          <a:bodyPr wrap="none" rtlCol="0">
+            <a:spAutoFit/>
+          </a:bodyPr>
+          <a:lstStyle/>
+          <a:p>
+            <a:r>
+              <a:rPr lang="en-US" altLang="zh-TW" dirty="0" smtClean="0"/>
+              <a:t>800</a:t>
+            </a:r>
+            <a:r>
+              <a:rPr lang="zh-TW" altLang="en-US" dirty="0" smtClean="0"/>
+              <a:t> </a:t>
+            </a:r>
+            <a:r>
+              <a:rPr lang="en-US" altLang="zh-TW" dirty="0" smtClean="0"/>
+              <a:t>-200</a:t>
+            </a:r>
+            <a:endParaRPr lang="zh-TW" altLang="en-US" dirty="0"/>
+          </a:p>
+        </p:txBody>
+      </p:sp>
+    </p:spTree>
+    <p:extLst>
+      <p:ext uri="{BB962C8B-B14F-4D97-AF65-F5344CB8AC3E}">
+        <p14:creationId xmlns:p14="http://schemas.microsoft.com/office/powerpoint/2010/main" val="3056459978"/>
+      </p:ext>
+    </p:extLst>
+  </p:cSld>
+  <p:clrMapOvr>
+    <a:masterClrMapping/>
+  </p:clrMapOvr>
+</p:sld>
+</file>
+
+<file path=ppt/slides/slide23.xml><?xml version="1.0" encoding="utf-8"?>
+<p:sld xmlns:a="http://schemas.openxmlformats.org/drawingml/2006/main" xmlns:r="http://schemas.openxmlformats.org/officeDocument/2006/relationships" xmlns:p="http://schemas.openxmlformats.org/presentationml/2006/main">
+  <p:cSld>
+    <p:spTree>
+      <p:nvGrpSpPr>
+        <p:cNvPr id="1" name=""/>
+        <p:cNvGrpSpPr/>
+        <p:nvPr/>
+      </p:nvGrpSpPr>
+      <p:grpSpPr>
+        <a:xfrm>
+          <a:off x="0" y="0"/>
+          <a:ext cx="0" cy="0"/>
+          <a:chOff x="0" y="0"/>
+          <a:chExt cx="0" cy="0"/>
+        </a:xfrm>
+      </p:grpSpPr>
+      <p:sp>
+        <p:nvSpPr>
+          <p:cNvPr id="2" name="標題 1"/>
+          <p:cNvSpPr>
+            <a:spLocks noGrp="1"/>
+          </p:cNvSpPr>
+          <p:nvPr>
+            <p:ph type="title"/>
+          </p:nvPr>
+        </p:nvSpPr>
+        <p:spPr/>
+        <p:txBody>
+          <a:bodyPr/>
+          <a:lstStyle/>
+          <a:p>
+            <a:endParaRPr lang="zh-TW" altLang="en-US"/>
+          </a:p>
+        </p:txBody>
+      </p:sp>
+      <p:pic>
+        <p:nvPicPr>
+          <p:cNvPr id="5" name="Picture 2"/>
+          <p:cNvPicPr>
+            <a:picLocks noGrp="1" noChangeAspect="1" noChangeArrowheads="1"/>
+          </p:cNvPicPr>
+          <p:nvPr>
+            <p:ph idx="1"/>
+          </p:nvPr>
+        </p:nvPicPr>
+        <p:blipFill>
+          <a:blip r:embed="rId2">
+            <a:extLst>
+              <a:ext uri="{28A0092B-C50C-407E-A947-70E740481C1C}">
+                <a14:useLocalDpi xmlns:a14="http://schemas.microsoft.com/office/drawing/2010/main" val="0"/>
+              </a:ext>
+            </a:extLst>
+          </a:blip>
+          <a:srcRect/>
+          <a:stretch>
+            <a:fillRect/>
+          </a:stretch>
+        </p:blipFill>
+        <p:spPr bwMode="auto">
+          <a:xfrm>
+            <a:off x="755576" y="752178"/>
+            <a:ext cx="6592537" cy="5373985"/>
+          </a:xfrm>
+          <a:prstGeom prst="rect">
+            <a:avLst/>
+          </a:prstGeom>
+          <a:noFill/>
+          <a:ln>
+            <a:noFill/>
+          </a:ln>
+          <a:effectLst/>
+          <a:extLst>
+            <a:ext uri="{909E8E84-426E-40DD-AFC4-6F175D3DCCD1}">
+              <a14:hiddenFill xmlns:a14="http://schemas.microsoft.com/office/drawing/2010/main">
+                <a:solidFill>
+                  <a:schemeClr val="accent1"/>
+                </a:solidFill>
+              </a14:hiddenFill>
+            </a:ext>
+            <a:ext uri="{91240B29-F687-4F45-9708-019B960494DF}">
+              <a14:hiddenLine xmlns:a14="http://schemas.microsoft.com/office/drawing/2010/main" w="9525">
+                <a:solidFill>
+                  <a:schemeClr val="tx1"/>
+                </a:solidFill>
+                <a:miter lim="800000"/>
+                <a:headEnd/>
+                <a:tailEnd/>
+              </a14:hiddenLine>
+            </a:ext>
+            <a:ext uri="{AF507438-7753-43E0-B8FC-AC1667EBCBE1}">
+              <a14:hiddenEffects xmlns:a14="http://schemas.microsoft.com/office/drawing/2010/main">
+                <a:effectLst>
+                  <a:outerShdw dist="35921" dir="2700000" algn="ctr" rotWithShape="0">
+                    <a:schemeClr val="bg2"/>
+                  </a:outerShdw>
+                </a:effectLst>
+              </a14:hiddenEffects>
+            </a:ext>
+          </a:extLst>
+        </p:spPr>
+      </p:pic>
+    </p:spTree>
+    <p:extLst>
+      <p:ext uri="{BB962C8B-B14F-4D97-AF65-F5344CB8AC3E}">
+        <p14:creationId xmlns:p14="http://schemas.microsoft.com/office/powerpoint/2010/main" val="3740888000"/>
+      </p:ext>
+    </p:extLst>
+  </p:cSld>
+  <p:clrMapOvr>
+    <a:masterClrMapping/>
+  </p:clrMapOvr>
+</p:sld>
+</file>
+
+<file path=ppt/slides/slide24.xml><?xml version="1.0" encoding="utf-8"?>
+<p:sld xmlns:a="http://schemas.openxmlformats.org/drawingml/2006/main" xmlns:r="http://schemas.openxmlformats.org/officeDocument/2006/relationships" xmlns:p="http://schemas.openxmlformats.org/presentationml/2006/main">
+  <p:cSld>
+    <p:spTree>
+      <p:nvGrpSpPr>
+        <p:cNvPr id="1" name=""/>
+        <p:cNvGrpSpPr/>
+        <p:nvPr/>
+      </p:nvGrpSpPr>
+      <p:grpSpPr>
+        <a:xfrm>
+          <a:off x="0" y="0"/>
+          <a:ext cx="0" cy="0"/>
+          <a:chOff x="0" y="0"/>
+          <a:chExt cx="0" cy="0"/>
+        </a:xfrm>
+      </p:grpSpPr>
+      <p:sp>
+        <p:nvSpPr>
+          <p:cNvPr id="2" name="標題 1"/>
+          <p:cNvSpPr>
+            <a:spLocks noGrp="1"/>
+          </p:cNvSpPr>
+          <p:nvPr>
+            <p:ph type="title"/>
+          </p:nvPr>
+        </p:nvSpPr>
+        <p:spPr/>
+        <p:txBody>
+          <a:bodyPr/>
+          <a:lstStyle/>
+          <a:p>
+            <a:endParaRPr lang="zh-TW" altLang="en-US"/>
+          </a:p>
+        </p:txBody>
+      </p:sp>
+      <p:pic>
+        <p:nvPicPr>
+          <p:cNvPr id="8194" name="Picture 2"/>
+          <p:cNvPicPr>
+            <a:picLocks noGrp="1" noChangeAspect="1" noChangeArrowheads="1"/>
+          </p:cNvPicPr>
+          <p:nvPr>
+            <p:ph idx="1"/>
+          </p:nvPr>
+        </p:nvPicPr>
+        <p:blipFill>
+          <a:blip r:embed="rId2">
+            <a:extLst>
+              <a:ext uri="{28A0092B-C50C-407E-A947-70E740481C1C}">
+                <a14:useLocalDpi xmlns:a14="http://schemas.microsoft.com/office/drawing/2010/main" val="0"/>
+              </a:ext>
+            </a:extLst>
+          </a:blip>
+          <a:srcRect/>
+          <a:stretch>
+            <a:fillRect/>
+          </a:stretch>
+        </p:blipFill>
+        <p:spPr bwMode="auto">
+          <a:xfrm>
+            <a:off x="3059832" y="548680"/>
+            <a:ext cx="5897984" cy="4525963"/>
+          </a:xfrm>
+          <a:prstGeom prst="rect">
+            <a:avLst/>
+          </a:prstGeom>
+          <a:noFill/>
+          <a:ln>
+            <a:noFill/>
+          </a:ln>
+          <a:effectLst/>
+          <a:extLst>
+            <a:ext uri="{909E8E84-426E-40DD-AFC4-6F175D3DCCD1}">
+              <a14:hiddenFill xmlns:a14="http://schemas.microsoft.com/office/drawing/2010/main">
+                <a:solidFill>
+                  <a:schemeClr val="accent1"/>
+                </a:solidFill>
+              </a14:hiddenFill>
+            </a:ext>
+            <a:ext uri="{91240B29-F687-4F45-9708-019B960494DF}">
+              <a14:hiddenLine xmlns:a14="http://schemas.microsoft.com/office/drawing/2010/main" w="9525">
+                <a:solidFill>
+                  <a:schemeClr val="tx1"/>
+                </a:solidFill>
+                <a:miter lim="800000"/>
+                <a:headEnd/>
+                <a:tailEnd/>
+              </a14:hiddenLine>
+            </a:ext>
+            <a:ext uri="{AF507438-7753-43E0-B8FC-AC1667EBCBE1}">
+              <a14:hiddenEffects xmlns:a14="http://schemas.microsoft.com/office/drawing/2010/main">
+                <a:effectLst>
+                  <a:outerShdw dist="35921" dir="2700000" algn="ctr" rotWithShape="0">
+                    <a:schemeClr val="bg2"/>
+                  </a:outerShdw>
+                </a:effectLst>
+              </a14:hiddenEffects>
+            </a:ext>
+          </a:extLst>
+        </p:spPr>
+      </p:pic>
+      <p:pic>
+        <p:nvPicPr>
+          <p:cNvPr id="8195" name="Picture 3"/>
+          <p:cNvPicPr>
+            <a:picLocks noChangeAspect="1" noChangeArrowheads="1"/>
+          </p:cNvPicPr>
+          <p:nvPr/>
+        </p:nvPicPr>
+        <p:blipFill>
+          <a:blip r:embed="rId3">
+            <a:extLst>
+              <a:ext uri="{28A0092B-C50C-407E-A947-70E740481C1C}">
+                <a14:useLocalDpi xmlns:a14="http://schemas.microsoft.com/office/drawing/2010/main" val="0"/>
+              </a:ext>
+            </a:extLst>
+          </a:blip>
+          <a:srcRect/>
+          <a:stretch>
+            <a:fillRect/>
+          </a:stretch>
+        </p:blipFill>
+        <p:spPr bwMode="auto">
+          <a:xfrm>
+            <a:off x="1" y="2533884"/>
+            <a:ext cx="6660232" cy="4026261"/>
+          </a:xfrm>
+          <a:prstGeom prst="rect">
+            <a:avLst/>
+          </a:prstGeom>
+          <a:noFill/>
+          <a:ln>
+            <a:noFill/>
+          </a:ln>
+          <a:effectLst/>
+          <a:extLst>
+            <a:ext uri="{909E8E84-426E-40DD-AFC4-6F175D3DCCD1}">
+              <a14:hiddenFill xmlns:a14="http://schemas.microsoft.com/office/drawing/2010/main">
+                <a:solidFill>
+                  <a:schemeClr val="accent1"/>
+                </a:solidFill>
+              </a14:hiddenFill>
+            </a:ext>
+            <a:ext uri="{91240B29-F687-4F45-9708-019B960494DF}">
+              <a14:hiddenLine xmlns:a14="http://schemas.microsoft.com/office/drawing/2010/main" w="9525">
+                <a:solidFill>
+                  <a:schemeClr val="tx1"/>
+                </a:solidFill>
+                <a:miter lim="800000"/>
+                <a:headEnd/>
+                <a:tailEnd/>
+              </a14:hiddenLine>
+            </a:ext>
+            <a:ext uri="{AF507438-7753-43E0-B8FC-AC1667EBCBE1}">
+              <a14:hiddenEffects xmlns:a14="http://schemas.microsoft.com/office/drawing/2010/main">
+                <a:effectLst>
+                  <a:outerShdw dist="35921" dir="2700000" algn="ctr" rotWithShape="0">
+                    <a:schemeClr val="bg2"/>
+                  </a:outerShdw>
+                </a:effectLst>
+              </a14:hiddenEffects>
+            </a:ext>
+          </a:extLst>
+        </p:spPr>
+      </p:pic>
+      <p:sp>
+        <p:nvSpPr>
+          <p:cNvPr id="4" name="文字方塊 3"/>
+          <p:cNvSpPr txBox="1"/>
+          <p:nvPr/>
+        </p:nvSpPr>
+        <p:spPr>
+          <a:xfrm>
+            <a:off x="611560" y="1844824"/>
+            <a:ext cx="1010213" cy="369332"/>
+          </a:xfrm>
+          <a:prstGeom prst="rect">
+            <a:avLst/>
+          </a:prstGeom>
+          <a:noFill/>
+        </p:spPr>
+        <p:txBody>
+          <a:bodyPr wrap="none" rtlCol="0">
+            <a:spAutoFit/>
+          </a:bodyPr>
+          <a:lstStyle/>
+          <a:p>
+            <a:r>
+              <a:rPr lang="en-US" altLang="zh-TW" dirty="0" smtClean="0"/>
+              <a:t>800</a:t>
+            </a:r>
+            <a:r>
+              <a:rPr lang="zh-TW" altLang="en-US" dirty="0" smtClean="0"/>
+              <a:t> </a:t>
+            </a:r>
+            <a:r>
+              <a:rPr lang="en-US" altLang="zh-TW" dirty="0" smtClean="0"/>
+              <a:t>-200</a:t>
+            </a:r>
+            <a:endParaRPr lang="zh-TW" altLang="en-US" dirty="0"/>
+          </a:p>
+        </p:txBody>
+      </p:sp>
+    </p:spTree>
+    <p:extLst>
+      <p:ext uri="{BB962C8B-B14F-4D97-AF65-F5344CB8AC3E}">
+        <p14:creationId xmlns:p14="http://schemas.microsoft.com/office/powerpoint/2010/main" val="1532126350"/>
+      </p:ext>
+    </p:extLst>
+  </p:cSld>
+  <p:clrMapOvr>
+    <a:masterClrMapping/>
+  </p:clrMapOvr>
+</p:sld>
+</file>
+
+<file path=ppt/slides/slide25.xml><?xml version="1.0" encoding="utf-8"?>
+<p:sld xmlns:a="http://schemas.openxmlformats.org/drawingml/2006/main" xmlns:r="http://schemas.openxmlformats.org/officeDocument/2006/relationships" xmlns:p="http://schemas.openxmlformats.org/presentationml/2006/main">
+  <p:cSld>
+    <p:spTree>
+      <p:nvGrpSpPr>
+        <p:cNvPr id="1" name=""/>
+        <p:cNvGrpSpPr/>
+        <p:nvPr/>
+      </p:nvGrpSpPr>
+      <p:grpSpPr>
+        <a:xfrm>
+          <a:off x="0" y="0"/>
+          <a:ext cx="0" cy="0"/>
+          <a:chOff x="0" y="0"/>
+          <a:chExt cx="0" cy="0"/>
+        </a:xfrm>
+      </p:grpSpPr>
+      <p:sp>
+        <p:nvSpPr>
+          <p:cNvPr id="2" name="標題 1"/>
+          <p:cNvSpPr>
+            <a:spLocks noGrp="1"/>
+          </p:cNvSpPr>
+          <p:nvPr>
+            <p:ph type="title"/>
+          </p:nvPr>
+        </p:nvSpPr>
+        <p:spPr/>
+        <p:txBody>
+          <a:bodyPr/>
+          <a:lstStyle/>
+          <a:p>
+            <a:endParaRPr lang="zh-TW" altLang="en-US"/>
+          </a:p>
+        </p:txBody>
+      </p:sp>
+      <p:pic>
+        <p:nvPicPr>
+          <p:cNvPr id="22531" name="Picture 3"/>
+          <p:cNvPicPr>
+            <a:picLocks noGrp="1" noChangeAspect="1" noChangeArrowheads="1"/>
+          </p:cNvPicPr>
+          <p:nvPr>
+            <p:ph idx="1"/>
+          </p:nvPr>
+        </p:nvPicPr>
+        <p:blipFill>
+          <a:blip r:embed="rId2">
+            <a:extLst>
+              <a:ext uri="{28A0092B-C50C-407E-A947-70E740481C1C}">
+                <a14:useLocalDpi xmlns:a14="http://schemas.microsoft.com/office/drawing/2010/main" val="0"/>
+              </a:ext>
+            </a:extLst>
+          </a:blip>
+          <a:srcRect/>
+          <a:stretch>
+            <a:fillRect/>
+          </a:stretch>
+        </p:blipFill>
+        <p:spPr bwMode="auto">
+          <a:xfrm>
+            <a:off x="457200" y="1816687"/>
+            <a:ext cx="8229600" cy="4092989"/>
+          </a:xfrm>
+          <a:prstGeom prst="rect">
+            <a:avLst/>
+          </a:prstGeom>
+          <a:noFill/>
+          <a:ln>
+            <a:noFill/>
+          </a:ln>
+          <a:effectLst/>
+          <a:extLst>
+            <a:ext uri="{909E8E84-426E-40DD-AFC4-6F175D3DCCD1}">
+              <a14:hiddenFill xmlns:a14="http://schemas.microsoft.com/office/drawing/2010/main">
+                <a:solidFill>
+                  <a:schemeClr val="accent1"/>
+                </a:solidFill>
+              </a14:hiddenFill>
+            </a:ext>
+            <a:ext uri="{91240B29-F687-4F45-9708-019B960494DF}">
+              <a14:hiddenLine xmlns:a14="http://schemas.microsoft.com/office/drawing/2010/main" w="9525">
+                <a:solidFill>
+                  <a:schemeClr val="tx1"/>
+                </a:solidFill>
+                <a:miter lim="800000"/>
+                <a:headEnd/>
+                <a:tailEnd/>
+              </a14:hiddenLine>
+            </a:ext>
+            <a:ext uri="{AF507438-7753-43E0-B8FC-AC1667EBCBE1}">
+              <a14:hiddenEffects xmlns:a14="http://schemas.microsoft.com/office/drawing/2010/main">
+                <a:effectLst>
+                  <a:outerShdw dist="35921" dir="2700000" algn="ctr" rotWithShape="0">
+                    <a:schemeClr val="bg2"/>
+                  </a:outerShdw>
+                </a:effectLst>
+              </a14:hiddenEffects>
+            </a:ext>
+          </a:extLst>
+        </p:spPr>
+      </p:pic>
+    </p:spTree>
+    <p:extLst>
+      <p:ext uri="{BB962C8B-B14F-4D97-AF65-F5344CB8AC3E}">
+        <p14:creationId xmlns:p14="http://schemas.microsoft.com/office/powerpoint/2010/main" val="11003145"/>
+      </p:ext>
+    </p:extLst>
+  </p:cSld>
+  <p:clrMapOvr>
+    <a:masterClrMapping/>
+  </p:clrMapOvr>
+</p:sld>
+</file>
+
+<file path=ppt/slides/slide26.xml><?xml version="1.0" encoding="utf-8"?>
+<p:sld xmlns:a="http://schemas.openxmlformats.org/drawingml/2006/main" xmlns:r="http://schemas.openxmlformats.org/officeDocument/2006/relationships" xmlns:p="http://schemas.openxmlformats.org/presentationml/2006/main">
+  <p:cSld>
+    <p:spTree>
+      <p:nvGrpSpPr>
+        <p:cNvPr id="1" name=""/>
+        <p:cNvGrpSpPr/>
+        <p:nvPr/>
+      </p:nvGrpSpPr>
+      <p:grpSpPr>
+        <a:xfrm>
+          <a:off x="0" y="0"/>
+          <a:ext cx="0" cy="0"/>
+          <a:chOff x="0" y="0"/>
+          <a:chExt cx="0" cy="0"/>
+        </a:xfrm>
+      </p:grpSpPr>
+      <p:sp>
+        <p:nvSpPr>
+          <p:cNvPr id="2" name="標題 1"/>
+          <p:cNvSpPr>
+            <a:spLocks noGrp="1"/>
+          </p:cNvSpPr>
+          <p:nvPr>
+            <p:ph type="title"/>
+          </p:nvPr>
+        </p:nvSpPr>
+        <p:spPr/>
+        <p:txBody>
+          <a:bodyPr/>
+          <a:lstStyle/>
+          <a:p>
+            <a:endParaRPr lang="zh-TW" altLang="en-US"/>
+          </a:p>
+        </p:txBody>
+      </p:sp>
+      <p:pic>
+        <p:nvPicPr>
+          <p:cNvPr id="23554" name="Picture 2"/>
+          <p:cNvPicPr>
+            <a:picLocks noGrp="1" noChangeAspect="1" noChangeArrowheads="1"/>
+          </p:cNvPicPr>
+          <p:nvPr>
+            <p:ph idx="1"/>
+          </p:nvPr>
+        </p:nvPicPr>
+        <p:blipFill>
+          <a:blip r:embed="rId2">
+            <a:extLst>
+              <a:ext uri="{28A0092B-C50C-407E-A947-70E740481C1C}">
+                <a14:useLocalDpi xmlns:a14="http://schemas.microsoft.com/office/drawing/2010/main" val="0"/>
+              </a:ext>
+            </a:extLst>
+          </a:blip>
+          <a:srcRect/>
+          <a:stretch>
+            <a:fillRect/>
+          </a:stretch>
+        </p:blipFill>
+        <p:spPr bwMode="auto">
+          <a:xfrm>
+            <a:off x="457200" y="1831563"/>
+            <a:ext cx="8229600" cy="4063236"/>
+          </a:xfrm>
+          <a:prstGeom prst="rect">
+            <a:avLst/>
+          </a:prstGeom>
+          <a:noFill/>
+          <a:ln>
+            <a:noFill/>
+          </a:ln>
+          <a:effectLst/>
+          <a:extLst>
+            <a:ext uri="{909E8E84-426E-40DD-AFC4-6F175D3DCCD1}">
+              <a14:hiddenFill xmlns:a14="http://schemas.microsoft.com/office/drawing/2010/main">
+                <a:solidFill>
+                  <a:schemeClr val="accent1"/>
+                </a:solidFill>
+              </a14:hiddenFill>
+            </a:ext>
+            <a:ext uri="{91240B29-F687-4F45-9708-019B960494DF}">
+              <a14:hiddenLine xmlns:a14="http://schemas.microsoft.com/office/drawing/2010/main" w="9525">
+                <a:solidFill>
+                  <a:schemeClr val="tx1"/>
+                </a:solidFill>
+                <a:miter lim="800000"/>
+                <a:headEnd/>
+                <a:tailEnd/>
+              </a14:hiddenLine>
+            </a:ext>
+            <a:ext uri="{AF507438-7753-43E0-B8FC-AC1667EBCBE1}">
+              <a14:hiddenEffects xmlns:a14="http://schemas.microsoft.com/office/drawing/2010/main">
+                <a:effectLst>
+                  <a:outerShdw dist="35921" dir="2700000" algn="ctr" rotWithShape="0">
+                    <a:schemeClr val="bg2"/>
+                  </a:outerShdw>
+                </a:effectLst>
+              </a14:hiddenEffects>
+            </a:ext>
+          </a:extLst>
+        </p:spPr>
+      </p:pic>
+    </p:spTree>
+    <p:extLst>
+      <p:ext uri="{BB962C8B-B14F-4D97-AF65-F5344CB8AC3E}">
+        <p14:creationId xmlns:p14="http://schemas.microsoft.com/office/powerpoint/2010/main" val="4026862449"/>
+      </p:ext>
+    </p:extLst>
+  </p:cSld>
+  <p:clrMapOvr>
+    <a:masterClrMapping/>
+  </p:clrMapOvr>
+</p:sld>
+</file>
+
+<file path=ppt/slides/slide27.xml><?xml version="1.0" encoding="utf-8"?>
+<p:sld xmlns:a="http://schemas.openxmlformats.org/drawingml/2006/main" xmlns:r="http://schemas.openxmlformats.org/officeDocument/2006/relationships" xmlns:p="http://schemas.openxmlformats.org/presentationml/2006/main">
+  <p:cSld>
+    <p:spTree>
+      <p:nvGrpSpPr>
+        <p:cNvPr id="1" name=""/>
+        <p:cNvGrpSpPr/>
+        <p:nvPr/>
+      </p:nvGrpSpPr>
+      <p:grpSpPr>
+        <a:xfrm>
+          <a:off x="0" y="0"/>
+          <a:ext cx="0" cy="0"/>
+          <a:chOff x="0" y="0"/>
+          <a:chExt cx="0" cy="0"/>
+        </a:xfrm>
+      </p:grpSpPr>
+      <p:sp>
+        <p:nvSpPr>
+          <p:cNvPr id="2" name="標題 1"/>
+          <p:cNvSpPr>
+            <a:spLocks noGrp="1"/>
+          </p:cNvSpPr>
+          <p:nvPr>
+            <p:ph type="title"/>
+          </p:nvPr>
+        </p:nvSpPr>
+        <p:spPr/>
+        <p:txBody>
+          <a:bodyPr/>
+          <a:lstStyle/>
+          <a:p>
+            <a:endParaRPr lang="zh-TW" altLang="en-US"/>
+          </a:p>
+        </p:txBody>
+      </p:sp>
+      <p:pic>
+        <p:nvPicPr>
+          <p:cNvPr id="24578" name="Picture 2"/>
+          <p:cNvPicPr>
+            <a:picLocks noGrp="1" noChangeAspect="1" noChangeArrowheads="1"/>
+          </p:cNvPicPr>
+          <p:nvPr>
+            <p:ph idx="1"/>
+          </p:nvPr>
+        </p:nvPicPr>
+        <p:blipFill>
+          <a:blip r:embed="rId2">
+            <a:extLst>
+              <a:ext uri="{28A0092B-C50C-407E-A947-70E740481C1C}">
+                <a14:useLocalDpi xmlns:a14="http://schemas.microsoft.com/office/drawing/2010/main" val="0"/>
+              </a:ext>
+            </a:extLst>
+          </a:blip>
+          <a:srcRect/>
+          <a:stretch>
+            <a:fillRect/>
+          </a:stretch>
+        </p:blipFill>
+        <p:spPr bwMode="auto">
+          <a:xfrm>
+            <a:off x="457200" y="2245073"/>
+            <a:ext cx="8229600" cy="3236217"/>
+          </a:xfrm>
+          <a:prstGeom prst="rect">
+            <a:avLst/>
+          </a:prstGeom>
+          <a:noFill/>
+          <a:ln>
+            <a:noFill/>
+          </a:ln>
+          <a:effectLst/>
+          <a:extLst>
+            <a:ext uri="{909E8E84-426E-40DD-AFC4-6F175D3DCCD1}">
+              <a14:hiddenFill xmlns:a14="http://schemas.microsoft.com/office/drawing/2010/main">
+                <a:solidFill>
+                  <a:schemeClr val="accent1"/>
+                </a:solidFill>
+              </a14:hiddenFill>
+            </a:ext>
+            <a:ext uri="{91240B29-F687-4F45-9708-019B960494DF}">
+              <a14:hiddenLine xmlns:a14="http://schemas.microsoft.com/office/drawing/2010/main" w="9525">
+                <a:solidFill>
+                  <a:schemeClr val="tx1"/>
+                </a:solidFill>
+                <a:miter lim="800000"/>
+                <a:headEnd/>
+                <a:tailEnd/>
+              </a14:hiddenLine>
+            </a:ext>
+            <a:ext uri="{AF507438-7753-43E0-B8FC-AC1667EBCBE1}">
+              <a14:hiddenEffects xmlns:a14="http://schemas.microsoft.com/office/drawing/2010/main">
+                <a:effectLst>
+                  <a:outerShdw dist="35921" dir="2700000" algn="ctr" rotWithShape="0">
+                    <a:schemeClr val="bg2"/>
+                  </a:outerShdw>
+                </a:effectLst>
+              </a14:hiddenEffects>
+            </a:ext>
+          </a:extLst>
+        </p:spPr>
+      </p:pic>
+    </p:spTree>
+    <p:extLst>
+      <p:ext uri="{BB962C8B-B14F-4D97-AF65-F5344CB8AC3E}">
+        <p14:creationId xmlns:p14="http://schemas.microsoft.com/office/powerpoint/2010/main" val="3669839688"/>
+      </p:ext>
+    </p:extLst>
+  </p:cSld>
+  <p:clrMapOvr>
+    <a:masterClrMapping/>
+  </p:clrMapOvr>
+</p:sld>
+</file>
+
+<file path=ppt/slides/slide28.xml><?xml version="1.0" encoding="utf-8"?>
+<p:sld xmlns:a="http://schemas.openxmlformats.org/drawingml/2006/main" xmlns:r="http://schemas.openxmlformats.org/officeDocument/2006/relationships" xmlns:p="http://schemas.openxmlformats.org/presentationml/2006/main">
+  <p:cSld>
+    <p:spTree>
+      <p:nvGrpSpPr>
+        <p:cNvPr id="1" name=""/>
+        <p:cNvGrpSpPr/>
+        <p:nvPr/>
+      </p:nvGrpSpPr>
+      <p:grpSpPr>
+        <a:xfrm>
+          <a:off x="0" y="0"/>
+          <a:ext cx="0" cy="0"/>
+          <a:chOff x="0" y="0"/>
+          <a:chExt cx="0" cy="0"/>
+        </a:xfrm>
+      </p:grpSpPr>
+      <p:sp>
+        <p:nvSpPr>
+          <p:cNvPr id="2" name="標題 1"/>
+          <p:cNvSpPr>
+            <a:spLocks noGrp="1"/>
+          </p:cNvSpPr>
+          <p:nvPr>
+            <p:ph type="title"/>
+          </p:nvPr>
+        </p:nvSpPr>
+        <p:spPr/>
+        <p:txBody>
+          <a:bodyPr/>
+          <a:lstStyle/>
+          <a:p>
+            <a:endParaRPr lang="zh-TW" altLang="en-US"/>
+          </a:p>
+        </p:txBody>
+      </p:sp>
+      <p:pic>
+        <p:nvPicPr>
+          <p:cNvPr id="26626" name="Picture 2"/>
+          <p:cNvPicPr>
+            <a:picLocks noGrp="1" noChangeAspect="1" noChangeArrowheads="1"/>
+          </p:cNvPicPr>
+          <p:nvPr>
+            <p:ph idx="1"/>
+          </p:nvPr>
+        </p:nvPicPr>
+        <p:blipFill>
+          <a:blip r:embed="rId2">
+            <a:extLst>
+              <a:ext uri="{28A0092B-C50C-407E-A947-70E740481C1C}">
+                <a14:useLocalDpi xmlns:a14="http://schemas.microsoft.com/office/drawing/2010/main" val="0"/>
+              </a:ext>
+            </a:extLst>
+          </a:blip>
+          <a:srcRect/>
+          <a:stretch>
+            <a:fillRect/>
+          </a:stretch>
+        </p:blipFill>
+        <p:spPr bwMode="auto">
+          <a:xfrm>
+            <a:off x="457200" y="2245073"/>
+            <a:ext cx="8229600" cy="3236217"/>
+          </a:xfrm>
+          <a:prstGeom prst="rect">
+            <a:avLst/>
+          </a:prstGeom>
+          <a:noFill/>
+          <a:ln>
+            <a:noFill/>
+          </a:ln>
+          <a:effectLst/>
+          <a:extLst>
+            <a:ext uri="{909E8E84-426E-40DD-AFC4-6F175D3DCCD1}">
+              <a14:hiddenFill xmlns:a14="http://schemas.microsoft.com/office/drawing/2010/main">
+                <a:solidFill>
+                  <a:schemeClr val="accent1"/>
+                </a:solidFill>
+              </a14:hiddenFill>
+            </a:ext>
+            <a:ext uri="{91240B29-F687-4F45-9708-019B960494DF}">
+              <a14:hiddenLine xmlns:a14="http://schemas.microsoft.com/office/drawing/2010/main" w="9525">
+                <a:solidFill>
+                  <a:schemeClr val="tx1"/>
+                </a:solidFill>
+                <a:miter lim="800000"/>
+                <a:headEnd/>
+                <a:tailEnd/>
+              </a14:hiddenLine>
+            </a:ext>
+            <a:ext uri="{AF507438-7753-43E0-B8FC-AC1667EBCBE1}">
+              <a14:hiddenEffects xmlns:a14="http://schemas.microsoft.com/office/drawing/2010/main">
+                <a:effectLst>
+                  <a:outerShdw dist="35921" dir="2700000" algn="ctr" rotWithShape="0">
+                    <a:schemeClr val="bg2"/>
+                  </a:outerShdw>
+                </a:effectLst>
+              </a14:hiddenEffects>
+            </a:ext>
+          </a:extLst>
+        </p:spPr>
+      </p:pic>
+    </p:spTree>
+    <p:extLst>
+      <p:ext uri="{BB962C8B-B14F-4D97-AF65-F5344CB8AC3E}">
+        <p14:creationId xmlns:p14="http://schemas.microsoft.com/office/powerpoint/2010/main" val="811302255"/>
+      </p:ext>
+    </p:extLst>
+  </p:cSld>
+  <p:clrMapOvr>
+    <a:masterClrMapping/>
+  </p:clrMapOvr>
+</p:sld>
+</file>
+
+<file path=ppt/slides/slide29.xml><?xml version="1.0" encoding="utf-8"?>
+<p:sld xmlns:a="http://schemas.openxmlformats.org/drawingml/2006/main" xmlns:r="http://schemas.openxmlformats.org/officeDocument/2006/relationships" xmlns:p="http://schemas.openxmlformats.org/presentationml/2006/main">
+  <p:cSld>
+    <p:spTree>
+      <p:nvGrpSpPr>
+        <p:cNvPr id="1" name=""/>
+        <p:cNvGrpSpPr/>
+        <p:nvPr/>
+      </p:nvGrpSpPr>
+      <p:grpSpPr>
+        <a:xfrm>
+          <a:off x="0" y="0"/>
+          <a:ext cx="0" cy="0"/>
+          <a:chOff x="0" y="0"/>
+          <a:chExt cx="0" cy="0"/>
+        </a:xfrm>
+      </p:grpSpPr>
+      <p:sp>
+        <p:nvSpPr>
+          <p:cNvPr id="2" name="標題 1"/>
+          <p:cNvSpPr>
+            <a:spLocks noGrp="1"/>
+          </p:cNvSpPr>
+          <p:nvPr>
+            <p:ph type="title"/>
+          </p:nvPr>
+        </p:nvSpPr>
+        <p:spPr/>
+        <p:txBody>
+          <a:bodyPr/>
+          <a:lstStyle/>
+          <a:p>
+            <a:endParaRPr lang="zh-TW" altLang="en-US"/>
+          </a:p>
+        </p:txBody>
+      </p:sp>
+      <p:pic>
+        <p:nvPicPr>
+          <p:cNvPr id="25602" name="Picture 2"/>
+          <p:cNvPicPr>
+            <a:picLocks noGrp="1" noChangeAspect="1" noChangeArrowheads="1"/>
+          </p:cNvPicPr>
+          <p:nvPr>
+            <p:ph idx="1"/>
+          </p:nvPr>
+        </p:nvPicPr>
+        <p:blipFill>
+          <a:blip r:embed="rId2">
+            <a:extLst>
+              <a:ext uri="{28A0092B-C50C-407E-A947-70E740481C1C}">
+                <a14:useLocalDpi xmlns:a14="http://schemas.microsoft.com/office/drawing/2010/main" val="0"/>
+              </a:ext>
+            </a:extLst>
+          </a:blip>
+          <a:srcRect/>
+          <a:stretch>
+            <a:fillRect/>
+          </a:stretch>
+        </p:blipFill>
+        <p:spPr bwMode="auto">
+          <a:xfrm>
+            <a:off x="457200" y="2245073"/>
+            <a:ext cx="8229600" cy="3236217"/>
+          </a:xfrm>
+          <a:prstGeom prst="rect">
+            <a:avLst/>
+          </a:prstGeom>
+          <a:noFill/>
+          <a:ln>
+            <a:noFill/>
+          </a:ln>
+          <a:effectLst/>
+          <a:extLst>
+            <a:ext uri="{909E8E84-426E-40DD-AFC4-6F175D3DCCD1}">
+              <a14:hiddenFill xmlns:a14="http://schemas.microsoft.com/office/drawing/2010/main">
+                <a:solidFill>
+                  <a:schemeClr val="accent1"/>
+                </a:solidFill>
+              </a14:hiddenFill>
+            </a:ext>
+            <a:ext uri="{91240B29-F687-4F45-9708-019B960494DF}">
+              <a14:hiddenLine xmlns:a14="http://schemas.microsoft.com/office/drawing/2010/main" w="9525">
+                <a:solidFill>
+                  <a:schemeClr val="tx1"/>
+                </a:solidFill>
+                <a:miter lim="800000"/>
+                <a:headEnd/>
+                <a:tailEnd/>
+              </a14:hiddenLine>
+            </a:ext>
+            <a:ext uri="{AF507438-7753-43E0-B8FC-AC1667EBCBE1}">
+              <a14:hiddenEffects xmlns:a14="http://schemas.microsoft.com/office/drawing/2010/main">
+                <a:effectLst>
+                  <a:outerShdw dist="35921" dir="2700000" algn="ctr" rotWithShape="0">
+                    <a:schemeClr val="bg2"/>
+                  </a:outerShdw>
+                </a:effectLst>
+              </a14:hiddenEffects>
+            </a:ext>
+          </a:extLst>
+        </p:spPr>
+      </p:pic>
+    </p:spTree>
+    <p:extLst>
+      <p:ext uri="{BB962C8B-B14F-4D97-AF65-F5344CB8AC3E}">
+        <p14:creationId xmlns:p14="http://schemas.microsoft.com/office/powerpoint/2010/main" val="3505212880"/>
       </p:ext>
     </p:extLst>
   </p:cSld>
@@ -3411,6 +6157,121 @@
     <p:extLst>
       <p:ext uri="{BB962C8B-B14F-4D97-AF65-F5344CB8AC3E}">
         <p14:creationId xmlns:p14="http://schemas.microsoft.com/office/powerpoint/2010/main" val="2435522"/>
+      </p:ext>
+    </p:extLst>
+  </p:cSld>
+  <p:clrMapOvr>
+    <a:masterClrMapping/>
+  </p:clrMapOvr>
+</p:sld>
+</file>
+
+<file path=ppt/slides/slide30.xml><?xml version="1.0" encoding="utf-8"?>
+<p:sld xmlns:a="http://schemas.openxmlformats.org/drawingml/2006/main" xmlns:r="http://schemas.openxmlformats.org/officeDocument/2006/relationships" xmlns:p="http://schemas.openxmlformats.org/presentationml/2006/main">
+  <p:cSld>
+    <p:spTree>
+      <p:nvGrpSpPr>
+        <p:cNvPr id="1" name=""/>
+        <p:cNvGrpSpPr/>
+        <p:nvPr/>
+      </p:nvGrpSpPr>
+      <p:grpSpPr>
+        <a:xfrm>
+          <a:off x="0" y="0"/>
+          <a:ext cx="0" cy="0"/>
+          <a:chOff x="0" y="0"/>
+          <a:chExt cx="0" cy="0"/>
+        </a:xfrm>
+      </p:grpSpPr>
+      <p:sp>
+        <p:nvSpPr>
+          <p:cNvPr id="2" name="標題 1"/>
+          <p:cNvSpPr>
+            <a:spLocks noGrp="1"/>
+          </p:cNvSpPr>
+          <p:nvPr>
+            <p:ph type="title"/>
+          </p:nvPr>
+        </p:nvSpPr>
+        <p:spPr/>
+        <p:txBody>
+          <a:bodyPr/>
+          <a:lstStyle/>
+          <a:p>
+            <a:endParaRPr lang="zh-TW" altLang="en-US"/>
+          </a:p>
+        </p:txBody>
+      </p:sp>
+      <p:pic>
+        <p:nvPicPr>
+          <p:cNvPr id="27650" name="Picture 2"/>
+          <p:cNvPicPr>
+            <a:picLocks noGrp="1" noChangeAspect="1" noChangeArrowheads="1"/>
+          </p:cNvPicPr>
+          <p:nvPr>
+            <p:ph idx="1"/>
+          </p:nvPr>
+        </p:nvPicPr>
+        <p:blipFill>
+          <a:blip r:embed="rId2">
+            <a:extLst>
+              <a:ext uri="{28A0092B-C50C-407E-A947-70E740481C1C}">
+                <a14:useLocalDpi xmlns:a14="http://schemas.microsoft.com/office/drawing/2010/main" val="0"/>
+              </a:ext>
+            </a:extLst>
+          </a:blip>
+          <a:srcRect/>
+          <a:stretch>
+            <a:fillRect/>
+          </a:stretch>
+        </p:blipFill>
+        <p:spPr bwMode="auto">
+          <a:xfrm>
+            <a:off x="457200" y="2245073"/>
+            <a:ext cx="8229600" cy="3236217"/>
+          </a:xfrm>
+          <a:prstGeom prst="rect">
+            <a:avLst/>
+          </a:prstGeom>
+          <a:noFill/>
+          <a:ln>
+            <a:noFill/>
+          </a:ln>
+          <a:effectLst/>
+          <a:extLst>
+            <a:ext uri="{909E8E84-426E-40DD-AFC4-6F175D3DCCD1}">
+              <a14:hiddenFill xmlns:a14="http://schemas.microsoft.com/office/drawing/2010/main">
+                <a:solidFill>
+                  <a:schemeClr val="accent1"/>
+                </a:solidFill>
+              </a14:hiddenFill>
+            </a:ext>
+            <a:ext uri="{91240B29-F687-4F45-9708-019B960494DF}">
+              <a14:hiddenLine xmlns:a14="http://schemas.microsoft.com/office/drawing/2010/main" w="9525">
+                <a:solidFill>
+                  <a:schemeClr val="tx1"/>
+                </a:solidFill>
+                <a:miter lim="800000"/>
+                <a:headEnd/>
+                <a:tailEnd/>
+              </a14:hiddenLine>
+            </a:ext>
+            <a:ext uri="{AF507438-7753-43E0-B8FC-AC1667EBCBE1}">
+              <a14:hiddenEffects xmlns:a14="http://schemas.microsoft.com/office/drawing/2010/main">
+                <a:effectLst>
+                  <a:outerShdw dist="35921" dir="2700000" algn="ctr" rotWithShape="0">
+                    <a:schemeClr val="bg2"/>
+                  </a:outerShdw>
+                </a:effectLst>
+              </a14:hiddenEffects>
+            </a:ext>
+          </a:extLst>
+        </p:spPr>
+      </p:pic>
+    </p:spTree>
+    <p:extLst>
+      <p:ext uri="{BB962C8B-B14F-4D97-AF65-F5344CB8AC3E}">
+        <p14:creationId xmlns:p14="http://schemas.microsoft.com/office/powerpoint/2010/main" val="1763135385"/>
       </p:ext>
     </p:extLst>
   </p:cSld>
@@ -3809,6 +6670,121 @@
           <a:bodyPr/>
           <a:lstStyle/>
           <a:p>
+            <a:endParaRPr lang="zh-TW" altLang="en-US"/>
+          </a:p>
+        </p:txBody>
+      </p:sp>
+      <p:pic>
+        <p:nvPicPr>
+          <p:cNvPr id="1026" name="Picture 2"/>
+          <p:cNvPicPr>
+            <a:picLocks noGrp="1" noChangeAspect="1" noChangeArrowheads="1"/>
+          </p:cNvPicPr>
+          <p:nvPr>
+            <p:ph idx="1"/>
+          </p:nvPr>
+        </p:nvPicPr>
+        <p:blipFill>
+          <a:blip r:embed="rId2">
+            <a:extLst>
+              <a:ext uri="{28A0092B-C50C-407E-A947-70E740481C1C}">
+                <a14:useLocalDpi xmlns:a14="http://schemas.microsoft.com/office/drawing/2010/main" val="0"/>
+              </a:ext>
+            </a:extLst>
+          </a:blip>
+          <a:srcRect/>
+          <a:stretch>
+            <a:fillRect/>
+          </a:stretch>
+        </p:blipFill>
+        <p:spPr bwMode="auto">
+          <a:xfrm>
+            <a:off x="1373131" y="1600200"/>
+            <a:ext cx="6397737" cy="4525963"/>
+          </a:xfrm>
+          <a:prstGeom prst="rect">
+            <a:avLst/>
+          </a:prstGeom>
+          <a:noFill/>
+          <a:ln>
+            <a:noFill/>
+          </a:ln>
+          <a:effectLst/>
+          <a:extLst>
+            <a:ext uri="{909E8E84-426E-40DD-AFC4-6F175D3DCCD1}">
+              <a14:hiddenFill xmlns:a14="http://schemas.microsoft.com/office/drawing/2010/main">
+                <a:solidFill>
+                  <a:schemeClr val="accent1"/>
+                </a:solidFill>
+              </a14:hiddenFill>
+            </a:ext>
+            <a:ext uri="{91240B29-F687-4F45-9708-019B960494DF}">
+              <a14:hiddenLine xmlns:a14="http://schemas.microsoft.com/office/drawing/2010/main" w="9525">
+                <a:solidFill>
+                  <a:schemeClr val="tx1"/>
+                </a:solidFill>
+                <a:miter lim="800000"/>
+                <a:headEnd/>
+                <a:tailEnd/>
+              </a14:hiddenLine>
+            </a:ext>
+            <a:ext uri="{AF507438-7753-43E0-B8FC-AC1667EBCBE1}">
+              <a14:hiddenEffects xmlns:a14="http://schemas.microsoft.com/office/drawing/2010/main">
+                <a:effectLst>
+                  <a:outerShdw dist="35921" dir="2700000" algn="ctr" rotWithShape="0">
+                    <a:schemeClr val="bg2"/>
+                  </a:outerShdw>
+                </a:effectLst>
+              </a14:hiddenEffects>
+            </a:ext>
+          </a:extLst>
+        </p:spPr>
+      </p:pic>
+    </p:spTree>
+    <p:extLst>
+      <p:ext uri="{BB962C8B-B14F-4D97-AF65-F5344CB8AC3E}">
+        <p14:creationId xmlns:p14="http://schemas.microsoft.com/office/powerpoint/2010/main" val="954523542"/>
+      </p:ext>
+    </p:extLst>
+  </p:cSld>
+  <p:clrMapOvr>
+    <a:masterClrMapping/>
+  </p:clrMapOvr>
+</p:sld>
+</file>
+
+<file path=ppt/slides/slide8.xml><?xml version="1.0" encoding="utf-8"?>
+<p:sld xmlns:a="http://schemas.openxmlformats.org/drawingml/2006/main" xmlns:r="http://schemas.openxmlformats.org/officeDocument/2006/relationships" xmlns:p="http://schemas.openxmlformats.org/presentationml/2006/main">
+  <p:cSld>
+    <p:spTree>
+      <p:nvGrpSpPr>
+        <p:cNvPr id="1" name=""/>
+        <p:cNvGrpSpPr/>
+        <p:nvPr/>
+      </p:nvGrpSpPr>
+      <p:grpSpPr>
+        <a:xfrm>
+          <a:off x="0" y="0"/>
+          <a:ext cx="0" cy="0"/>
+          <a:chOff x="0" y="0"/>
+          <a:chExt cx="0" cy="0"/>
+        </a:xfrm>
+      </p:grpSpPr>
+      <p:sp>
+        <p:nvSpPr>
+          <p:cNvPr id="2" name="標題 1"/>
+          <p:cNvSpPr>
+            <a:spLocks noGrp="1"/>
+          </p:cNvSpPr>
+          <p:nvPr>
+            <p:ph type="title"/>
+          </p:nvPr>
+        </p:nvSpPr>
+        <p:spPr/>
+        <p:txBody>
+          <a:bodyPr/>
+          <a:lstStyle/>
+          <a:p>
             <a:r>
               <a:rPr lang="en-US" altLang="zh-TW" dirty="0" smtClean="0"/>
               <a:t>Log</a:t>
@@ -3891,6 +6867,121 @@
     <p:extLst>
       <p:ext uri="{BB962C8B-B14F-4D97-AF65-F5344CB8AC3E}">
         <p14:creationId xmlns:p14="http://schemas.microsoft.com/office/powerpoint/2010/main" val="17775604"/>
+      </p:ext>
+    </p:extLst>
+  </p:cSld>
+  <p:clrMapOvr>
+    <a:masterClrMapping/>
+  </p:clrMapOvr>
+</p:sld>
+</file>
+
+<file path=ppt/slides/slide9.xml><?xml version="1.0" encoding="utf-8"?>
+<p:sld xmlns:a="http://schemas.openxmlformats.org/drawingml/2006/main" xmlns:r="http://schemas.openxmlformats.org/officeDocument/2006/relationships" xmlns:p="http://schemas.openxmlformats.org/presentationml/2006/main">
+  <p:cSld>
+    <p:spTree>
+      <p:nvGrpSpPr>
+        <p:cNvPr id="1" name=""/>
+        <p:cNvGrpSpPr/>
+        <p:nvPr/>
+      </p:nvGrpSpPr>
+      <p:grpSpPr>
+        <a:xfrm>
+          <a:off x="0" y="0"/>
+          <a:ext cx="0" cy="0"/>
+          <a:chOff x="0" y="0"/>
+          <a:chExt cx="0" cy="0"/>
+        </a:xfrm>
+      </p:grpSpPr>
+      <p:sp>
+        <p:nvSpPr>
+          <p:cNvPr id="2" name="標題 1"/>
+          <p:cNvSpPr>
+            <a:spLocks noGrp="1"/>
+          </p:cNvSpPr>
+          <p:nvPr>
+            <p:ph type="title"/>
+          </p:nvPr>
+        </p:nvSpPr>
+        <p:spPr/>
+        <p:txBody>
+          <a:bodyPr/>
+          <a:lstStyle/>
+          <a:p>
+            <a:endParaRPr lang="zh-TW" altLang="en-US"/>
+          </a:p>
+        </p:txBody>
+      </p:sp>
+      <p:pic>
+        <p:nvPicPr>
+          <p:cNvPr id="16386" name="Picture 2"/>
+          <p:cNvPicPr>
+            <a:picLocks noGrp="1" noChangeAspect="1" noChangeArrowheads="1"/>
+          </p:cNvPicPr>
+          <p:nvPr>
+            <p:ph idx="1"/>
+          </p:nvPr>
+        </p:nvPicPr>
+        <p:blipFill>
+          <a:blip r:embed="rId2">
+            <a:extLst>
+              <a:ext uri="{28A0092B-C50C-407E-A947-70E740481C1C}">
+                <a14:useLocalDpi xmlns:a14="http://schemas.microsoft.com/office/drawing/2010/main" val="0"/>
+              </a:ext>
+            </a:extLst>
+          </a:blip>
+          <a:srcRect/>
+          <a:stretch>
+            <a:fillRect/>
+          </a:stretch>
+        </p:blipFill>
+        <p:spPr bwMode="auto">
+          <a:xfrm>
+            <a:off x="611561" y="742568"/>
+            <a:ext cx="6832438" cy="5383596"/>
+          </a:xfrm>
+          <a:prstGeom prst="rect">
+            <a:avLst/>
+          </a:prstGeom>
+          <a:noFill/>
+          <a:ln>
+            <a:noFill/>
+          </a:ln>
+          <a:effectLst/>
+          <a:extLst>
+            <a:ext uri="{909E8E84-426E-40DD-AFC4-6F175D3DCCD1}">
+              <a14:hiddenFill xmlns:a14="http://schemas.microsoft.com/office/drawing/2010/main">
+                <a:solidFill>
+                  <a:schemeClr val="accent1"/>
+                </a:solidFill>
+              </a14:hiddenFill>
+            </a:ext>
+            <a:ext uri="{91240B29-F687-4F45-9708-019B960494DF}">
+              <a14:hiddenLine xmlns:a14="http://schemas.microsoft.com/office/drawing/2010/main" w="9525">
+                <a:solidFill>
+                  <a:schemeClr val="tx1"/>
+                </a:solidFill>
+                <a:miter lim="800000"/>
+                <a:headEnd/>
+                <a:tailEnd/>
+              </a14:hiddenLine>
+            </a:ext>
+            <a:ext uri="{AF507438-7753-43E0-B8FC-AC1667EBCBE1}">
+              <a14:hiddenEffects xmlns:a14="http://schemas.microsoft.com/office/drawing/2010/main">
+                <a:effectLst>
+                  <a:outerShdw dist="35921" dir="2700000" algn="ctr" rotWithShape="0">
+                    <a:schemeClr val="bg2"/>
+                  </a:outerShdw>
+                </a:effectLst>
+              </a14:hiddenEffects>
+            </a:ext>
+          </a:extLst>
+        </p:spPr>
+      </p:pic>
+    </p:spTree>
+    <p:extLst>
+      <p:ext uri="{BB962C8B-B14F-4D97-AF65-F5344CB8AC3E}">
+        <p14:creationId xmlns:p14="http://schemas.microsoft.com/office/powerpoint/2010/main" val="1144596879"/>
       </p:ext>
     </p:extLst>
   </p:cSld>

</xml_diff>